<commit_message>
Refocus on rain, riders and Mumbai, with phased roadmap
- Pitch video and page: rain-led story, riders on Kavach Plus, heat as
  phase two, four-phase roadmap (2:47)
- Presentation: where-to-start India slide, riders-first business slide,
  Mumbai pilot ask, new four-phases slide (9 slides)
- Drill book: focus and realism scorecard, who pays the Rs 300, Mumbai
  pilot plan, updated slide timings, 185 cross-questions

Co-Authored-By: Claude Opus 5.5 <noreply@anthropic.com>
Claude-Session: https://claude.ai/code/session_01EtNeZxsjtwkcfxMR3SBa6h
</commit_message>
<xml_diff>
--- a/reliance-tup-xii/JioMausam_3min_Presentation.pptx
+++ b/reliance-tup-xii/JioMausam_3min_Presentation.pptx
@@ -13,9 +13,10 @@
     <p:sldId id="261" r:id="rId7"/>
     <p:sldId id="262" r:id="rId8"/>
     <p:sldId id="263" r:id="rId9"/>
+    <p:sldId id="264" r:id="rId10"/>
   </p:sldIdLst>
   <p:notesMasterIdLst>
-    <p:notesMasterId r:id="rId10"/>
+    <p:notesMasterId r:id="rId11"/>
   </p:notesMasterIdLst>
   <p:sldSz cx="12192000" cy="6858000"/>
   <p:notesSz cx="6858000" cy="12192000"/>
@@ -114,7 +115,7 @@
   <p:extLst>
     <p:ext uri="{521415D9-36F7-43E2-AB2F-B90AF26B5E84}">
       <p14:sectionLst xmlns:p14="http://schemas.microsoft.com/office/powerpoint/2010/main">
-        <p14:section name="Elimination round" id="{c506f0b8-1c7b-92db-c6b0-63cc9183a385}">
+        <p14:section name="Elimination round" id="{59b0ea22-44e5-95e1-4ca0-2a76dbcbf034}">
           <p14:sldIdLst>
             <p14:sldId id="256"/>
             <p14:sldId id="257"/>
@@ -124,6 +125,7 @@
             <p14:sldId id="261"/>
             <p14:sldId id="262"/>
             <p14:sldId id="263"/>
+            <p14:sldId id="264"/>
           </p14:sldIdLst>
         </p14:section>
       </p14:sectionLst>
@@ -4565,7 +4567,7 @@
           <a:p>
             <a:r>
               <a:rPr lang="en-US" dirty="0"/>
-              <a:t>[0:00–0:15] You’ve just seen the idea. In the next three minutes we’ll show you three things: that it works on real network data, what it should cost in Indian cities, and exactly what we need from Reliance to launch it.</a:t>
+              <a:t>[0:00–0:12] You’ve just seen the idea. In the next three minutes: proof that it works on real network data, where we start and why, and exactly what we need from Reliance.</a:t>
             </a:r>
             <a:endParaRPr lang="en-US" dirty="0"/>
           </a:p>
@@ -4653,7 +4655,7 @@
           <a:p>
             <a:r>
               <a:rPr lang="en-US" dirty="0"/>
-              <a:t>[0:15–0:45] This is our working prototype, the JioMausam Control Room. On the left is rain mapped only from 500 real tower-to-tower radio links. On the right is a national weather radar that costs crores. Same storm, same moment. The shapes and the heavy patches match. We added nothing to the network to get this. (If the call allows, switch to the live prototype tab and press “Replay the storm”.)</a:t>
+              <a:t>[0:12–0:40] This is our working prototype, the JioMausam Control Room. On the left is rain mapped only from 500 real tower-to-tower radio links. On the right is a national weather radar that costs crores. Same storm, same moment. The shapes and the heavy patches match. We added nothing to the network to get this. (If the call allows, switch to the live prototype tab and press “Replay the storm”.)</a:t>
             </a:r>
             <a:endParaRPr lang="en-US" dirty="0"/>
           </a:p>
@@ -4741,7 +4743,7 @@
           <a:p>
             <a:r>
               <a:rPr lang="en-US" dirty="0"/>
-              <a:t>[0:45–1:10] Here’s the honest test. We tuned one number on the first three days, then tested on eight days the model had never seen. Network-wide our rain matched the radar at 0.95. A single link on its own: 0.88. We caught 91% of rainy days with only 4.6% false alarms. And our payout rule made the same pay or no-pay decision as the radar 94.6% of the time.</a:t>
+              <a:t>[0:40–1:00] Here’s the honest test. We tuned one number on the first three days, then tested on eight days the model had never seen. Network-wide our rain matched the radar at 0.95. A single link on its own: 0.88. We caught 91% of rainy days with only 4.6% false alarms. And our payout rule made the same pay or no-pay decision as the radar 94.6% of the time.</a:t>
             </a:r>
             <a:endParaRPr lang="en-US" dirty="0"/>
           </a:p>
@@ -4829,7 +4831,7 @@
           <a:p>
             <a:r>
               <a:rPr lang="en-US" dirty="0"/>
-              <a:t>[1:10–1:40] Indian operators don’t publish link data, so we went to 25 years of IMD station records. Two findings. First, rain really is hyperlocal: on a third of Mumbai’s heavy-rain days, the station 20 km away got less than half as much. Second, one flat price can’t work. Mumbai sees about 11.88 heavy-rain days a year; Nagpur about 9.68 days above 45 degrees. So Kavach Basic covers each city’s rare extreme days: ₹45 a month in Mumbai, ₹52 in Nagpur, ₹29 in Ahmedabad.</a:t>
+              <a:t>[1:00–1:25] Indian operators don’t publish link data, so we went to 25 years of IMD station records. Two findings. Rain really is hyperlocal: on a third of Mumbai’s heavy-rain days, a station 20 km away got less than half as much. And each city has a different danger. Mumbai sees about 12 heavy-rain days a year, so that’s where we start: rain, riders, Mumbai. Nagpur and Ahmedabad face heat, which is our phase two.</a:t>
             </a:r>
             <a:endParaRPr lang="en-US" dirty="0"/>
           </a:p>
@@ -4917,7 +4919,7 @@
           <a:p>
             <a:r>
               <a:rPr lang="en-US" dirty="0"/>
-              <a:t>[1:40–2:05] This is the Mausam Kavach app. Ravi, a delivery rider in Andheri, is covered: his delivery app pays for it. As the towers around him measure the rain, the ring fills. The moment it crosses ten millimetres in three hours, three hundred rupees lands in his JioPay wallet, with the exact reading that triggered it. No form, no surveyor. It works in Hindi too.</a:t>
+              <a:t>[1:25–1:50] This is the Mausam Kavach app. Ravi, a delivery rider in Andheri, is covered: his delivery app pays for it. As the towers around him measure the rain, the ring fills. The moment it crosses ten millimetres in three hours, three hundred rupees lands in his JioPay wallet, with the exact reading that triggered it. No form, no surveyor. It works in Hindi too.</a:t>
             </a:r>
             <a:endParaRPr lang="en-US" dirty="0"/>
           </a:p>
@@ -5005,7 +5007,7 @@
           <a:p>
             <a:r>
               <a:rPr lang="en-US" dirty="0"/>
-              <a:t>[2:05–2:30] It pays three ways. Individuals add Kavach Basic at recharge: one percent of Jio’s users is about 174 crore rupees a year. Delivery apps buy Kavach Plus for their riders: in Mumbai that’s ₹208 a rider a month, so fifty thousand riders is about 12.5 crore a year. And insurers and state disaster agencies license the data, while JioMart, New Energy and Jio use it first. Customer acquisition rides on the recharge, and settlement is automatic, so most of the premium goes back to people.</a:t>
+              <a:t>[1:50–2:15] We start with riders, because one deal with one delivery app covers thousands of workers. Kavach Plus in Mumbai costs about ₹208 a rider a month, so fifty thousand riders is about 12.5 crore a year. In phase three, anyone can add Kavach Basic at recharge, ₹29 to ₹52 by city; one percent of Jio’s users is 174 crore a year. And insurers, states, JioMart and New Energy use the data.</a:t>
             </a:r>
             <a:endParaRPr lang="en-US" dirty="0"/>
           </a:p>
@@ -5093,7 +5095,7 @@
           <a:p>
             <a:r>
               <a:rPr lang="en-US" dirty="0"/>
-              <a:t>[2:30–2:50] Why only Reliance? It takes five layers: a network to sense, half a billion people to reach, a way to pay, an insurer, and businesses that use the data. Reliance is the only company with all five under one roof. Our ask is small: a ninety-day pilot, rain in Vidarbha and heat in Ahmedabad, with link logs for two districts, one insurance partner, and a five-person team. No new hardware.</a:t>
+              <a:t>[2:15–2:35] Why only Reliance? It takes five layers: a network to sense, half a billion people to reach, a way to pay, an insurer, and businesses that use the data. Reliance is the only company with all five. Our ask is small: a ninety-day Mumbai monsoon pilot with Jio’s link logs for Mumbai, one insurance partner, one delivery app and a five-person team. No new hardware. It tests our two riskiest assumptions: link coverage and payout accuracy.</a:t>
             </a:r>
             <a:endParaRPr lang="en-US" dirty="0"/>
           </a:p>
@@ -5181,7 +5183,7 @@
           <a:p>
             <a:r>
               <a:rPr lang="en-US" dirty="0"/>
-              <a:t>[2:50–3:00] India won’t adapt to climate change by building more. It will adapt by listening to what it already has. This is JioMausam. Thank you.</a:t>
+              <a:t>[2:35–2:52] Four phases. Phase one is the Mumbai monsoon pilot: rain, riders, one delivery app. Phase two adds heatwaves in Nagpur and Ahmedabad. Phase three puts Kavach Basic on every recharge. Phase four is a national map with data for insurers and states.</a:t>
             </a:r>
             <a:endParaRPr lang="en-US" dirty="0"/>
           </a:p>
@@ -5205,6 +5207,94 @@
             <a:fld id="{F7021451-1387-4CA6-816F-3879F97B5CBC}" type="slidenum">
               <a:rPr lang="en-US"/>
               <a:t>8</a:t>
+            </a:fld>
+            <a:endParaRPr lang="en-US"/>
+          </a:p>
+        </p:txBody>
+      </p:sp>
+    </p:spTree>
+    <p:extLst>
+      <p:ext uri="{BB962C8B-B14F-4D97-AF65-F5344CB8AC3E}">
+        <p14:creationId xmlns:p14="http://schemas.microsoft.com/office/powerpoint/2010/main" val="1024086991"/>
+      </p:ext>
+    </p:extLst>
+  </p:cSld>
+  <p:clrMapOvr>
+    <a:masterClrMapping/>
+  </p:clrMapOvr>
+</p:notes>
+</file>
+
+<file path=ppt/notesSlides/notesSlide9.xml><?xml version="1.0" encoding="utf-8"?>
+<p:notes xmlns:a="http://schemas.openxmlformats.org/drawingml/2006/main" xmlns:r="http://schemas.openxmlformats.org/officeDocument/2006/relationships" xmlns:p="http://schemas.openxmlformats.org/presentationml/2006/main">
+  <p:cSld>
+    <p:spTree>
+      <p:nvGrpSpPr>
+        <p:cNvPr id="1" name=""/>
+        <p:cNvGrpSpPr/>
+        <p:nvPr/>
+      </p:nvGrpSpPr>
+      <p:grpSpPr>
+        <a:xfrm>
+          <a:off x="0" y="0"/>
+          <a:ext cx="0" cy="0"/>
+          <a:chOff x="0" y="0"/>
+          <a:chExt cx="0" cy="0"/>
+        </a:xfrm>
+      </p:grpSpPr>
+      <p:sp>
+        <p:nvSpPr>
+          <p:cNvPr id="2" name="Slide Image Placeholder 1"/>
+          <p:cNvSpPr>
+            <a:spLocks noGrp="1" noRot="1" noChangeAspect="1"/>
+          </p:cNvSpPr>
+          <p:nvPr>
+            <p:ph type="sldImg"/>
+          </p:nvPr>
+        </p:nvSpPr>
+        <p:spPr/>
+      </p:sp>
+      <p:sp>
+        <p:nvSpPr>
+          <p:cNvPr id="3" name="Notes Placeholder 2"/>
+          <p:cNvSpPr>
+            <a:spLocks noGrp="1"/>
+          </p:cNvSpPr>
+          <p:nvPr>
+            <p:ph type="body" idx="1"/>
+          </p:nvPr>
+        </p:nvSpPr>
+        <p:spPr/>
+        <p:txBody>
+          <a:bodyPr/>
+          <a:lstStyle/>
+          <a:p>
+            <a:r>
+              <a:rPr lang="en-US" dirty="0"/>
+              <a:t>[2:52–3:00] India won’t adapt to climate change by building more. It will adapt by listening to what it already has. This is JioMausam. Thank you.</a:t>
+            </a:r>
+            <a:endParaRPr lang="en-US" dirty="0"/>
+          </a:p>
+        </p:txBody>
+      </p:sp>
+      <p:sp>
+        <p:nvSpPr>
+          <p:cNvPr id="4" name="Slide Number Placeholder 3"/>
+          <p:cNvSpPr>
+            <a:spLocks noGrp="1"/>
+          </p:cNvSpPr>
+          <p:nvPr>
+            <p:ph type="sldNum" sz="quarter" idx="10"/>
+          </p:nvPr>
+        </p:nvSpPr>
+        <p:spPr/>
+        <p:txBody>
+          <a:bodyPr/>
+          <a:lstStyle/>
+          <a:p>
+            <a:fld id="{F7021451-1387-4CA6-816F-3879F97B5CBC}" type="slidenum">
+              <a:rPr lang="en-US"/>
+              <a:t>9</a:t>
             </a:fld>
             <a:endParaRPr lang="en-US"/>
           </a:p>
@@ -8159,7 +8249,7 @@
                 <a:ea typeface="Cambria" pitchFamily="34" charset="-122"/>
                 <a:cs typeface="Cambria" pitchFamily="34" charset="-120"/>
               </a:rPr>
-              <a:t>Indian weather changed our pricing.</a:t>
+              <a:t>Indian weather tells us where to start.</a:t>
             </a:r>
             <a:endParaRPr lang="en-US" sz="3400" dirty="0"/>
           </a:p>
@@ -8189,7 +8279,7 @@
         </p:nvSpPr>
         <p:spPr>
           <a:xfrm>
-            <a:off x="8092440" y="2148840"/>
+            <a:off x="8092440" y="2103120"/>
             <a:ext cx="3566160" cy="1554480"/>
           </a:xfrm>
           <a:prstGeom prst="rect">
@@ -8204,7 +8294,7 @@
           <a:p>
             <a:pPr indent="0" marL="0">
               <a:spcAft>
-                <a:spcPts val="600"/>
+                <a:spcPts val="400"/>
               </a:spcAft>
               <a:buNone/>
             </a:pPr>
@@ -8217,19 +8307,19 @@
                 <a:ea typeface="Cambria" pitchFamily="34" charset="-122"/>
                 <a:cs typeface="Cambria" pitchFamily="34" charset="-120"/>
               </a:rPr>
-              <a:t>One flat price can’t work.</a:t>
+              <a:t>Start where the triggers are.</a:t>
             </a:r>
             <a:endParaRPr lang="en-US" sz="2200" dirty="0"/>
           </a:p>
           <a:p>
             <a:pPr indent="0" marL="0">
               <a:spcAft>
-                <a:spcPts val="600"/>
+                <a:spcPts val="400"/>
               </a:spcAft>
               <a:buNone/>
             </a:pPr>
             <a:r>
-              <a:rPr lang="en-US" sz="1400" dirty="0">
+              <a:rPr lang="en-US" sz="1300" dirty="0">
                 <a:solidFill>
                   <a:srgbClr val="B9C2D8"/>
                 </a:solidFill>
@@ -8237,7 +8327,7 @@
                 <a:ea typeface="Calibri" pitchFamily="34" charset="-122"/>
                 <a:cs typeface="Calibri" pitchFamily="34" charset="-120"/>
               </a:rPr>
-              <a:t>Mumbai’s risk is rain. Nagpur’s and Ahmedabad’s is heat. So each city is priced on its own 25-year record.</a:t>
+              <a:t>Mumbai has about 12 heavy-rain days a year, so rain and riders come first. Nagpur’s and Ahmedabad’s danger is heat: that’s phase two.</a:t>
             </a:r>
             <a:endParaRPr lang="en-US" sz="2200" dirty="0"/>
           </a:p>
@@ -8279,7 +8369,7 @@
         <p:spPr>
           <a:xfrm>
             <a:off x="8275320" y="3840480"/>
-            <a:ext cx="2377440" cy="603504"/>
+            <a:ext cx="2240280" cy="603504"/>
           </a:xfrm>
           <a:prstGeom prst="rect">
             <a:avLst/>
@@ -8295,7 +8385,7 @@
               <a:buNone/>
             </a:pPr>
             <a:r>
-              <a:rPr lang="en-US" sz="1300" b="1" dirty="0">
+              <a:rPr lang="en-US" sz="1250" b="1" dirty="0">
                 <a:solidFill>
                   <a:srgbClr val="FFFFFF"/>
                 </a:solidFill>
@@ -8309,7 +8399,7 @@
               <a:buNone/>
             </a:pPr>
             <a:r>
-              <a:rPr lang="en-US" sz="1300" dirty="0">
+              <a:rPr lang="en-US" sz="1250" dirty="0">
                 <a:solidFill>
                   <a:srgbClr val="98A2C0"/>
                 </a:solidFill>
@@ -8317,9 +8407,9 @@
                 <a:ea typeface="Calibri" pitchFamily="34" charset="-122"/>
                 <a:cs typeface="Calibri" pitchFamily="34" charset="-120"/>
               </a:rPr>
-              <a:t>extremely heavy rain day</a:t>
+              <a:t>rain · 11.9 heavy days a year</a:t>
             </a:r>
-            <a:endParaRPr lang="en-US" sz="1300" dirty="0"/>
+            <a:endParaRPr lang="en-US" sz="1250" dirty="0"/>
           </a:p>
         </p:txBody>
       </p:sp>
@@ -8331,8 +8421,8 @@
         </p:nvSpPr>
         <p:spPr>
           <a:xfrm>
-            <a:off x="10561320" y="3840480"/>
-            <a:ext cx="960120" cy="603504"/>
+            <a:off x="10469880" y="3840480"/>
+            <a:ext cx="1051560" cy="603504"/>
           </a:xfrm>
           <a:prstGeom prst="rect">
             <a:avLst/>
@@ -8356,7 +8446,7 @@
                 <a:ea typeface="Cambria" pitchFamily="34" charset="-122"/>
                 <a:cs typeface="Cambria" pitchFamily="34" charset="-120"/>
               </a:rPr>
-              <a:t>₹45/mo</a:t>
+              <a:t>Phase 1</a:t>
             </a:r>
             <a:endParaRPr lang="en-US" sz="1700" dirty="0"/>
           </a:p>
@@ -8398,7 +8488,7 @@
         <p:spPr>
           <a:xfrm>
             <a:off x="8275320" y="4553712"/>
-            <a:ext cx="2377440" cy="603504"/>
+            <a:ext cx="2240280" cy="603504"/>
           </a:xfrm>
           <a:prstGeom prst="rect">
             <a:avLst/>
@@ -8414,7 +8504,7 @@
               <a:buNone/>
             </a:pPr>
             <a:r>
-              <a:rPr lang="en-US" sz="1300" b="1" dirty="0">
+              <a:rPr lang="en-US" sz="1250" b="1" dirty="0">
                 <a:solidFill>
                   <a:srgbClr val="FFFFFF"/>
                 </a:solidFill>
@@ -8428,7 +8518,7 @@
               <a:buNone/>
             </a:pPr>
             <a:r>
-              <a:rPr lang="en-US" sz="1300" dirty="0">
+              <a:rPr lang="en-US" sz="1250" dirty="0">
                 <a:solidFill>
                   <a:srgbClr val="98A2C0"/>
                 </a:solidFill>
@@ -8436,9 +8526,9 @@
                 <a:ea typeface="Calibri" pitchFamily="34" charset="-122"/>
                 <a:cs typeface="Calibri" pitchFamily="34" charset="-120"/>
               </a:rPr>
-              <a:t>47°C day</a:t>
+              <a:t>heat · 9.7 days ≥45°C</a:t>
             </a:r>
-            <a:endParaRPr lang="en-US" sz="1300" dirty="0"/>
+            <a:endParaRPr lang="en-US" sz="1250" dirty="0"/>
           </a:p>
         </p:txBody>
       </p:sp>
@@ -8450,8 +8540,8 @@
         </p:nvSpPr>
         <p:spPr>
           <a:xfrm>
-            <a:off x="10561320" y="4553712"/>
-            <a:ext cx="960120" cy="603504"/>
+            <a:off x="10469880" y="4553712"/>
+            <a:ext cx="1051560" cy="603504"/>
           </a:xfrm>
           <a:prstGeom prst="rect">
             <a:avLst/>
@@ -8475,7 +8565,7 @@
                 <a:ea typeface="Cambria" pitchFamily="34" charset="-122"/>
                 <a:cs typeface="Cambria" pitchFamily="34" charset="-120"/>
               </a:rPr>
-              <a:t>₹52/mo</a:t>
+              <a:t>Phase 2</a:t>
             </a:r>
             <a:endParaRPr lang="en-US" sz="1700" dirty="0"/>
           </a:p>
@@ -8517,7 +8607,7 @@
         <p:spPr>
           <a:xfrm>
             <a:off x="8275320" y="5266944"/>
-            <a:ext cx="2377440" cy="603504"/>
+            <a:ext cx="2240280" cy="603504"/>
           </a:xfrm>
           <a:prstGeom prst="rect">
             <a:avLst/>
@@ -8533,7 +8623,7 @@
               <a:buNone/>
             </a:pPr>
             <a:r>
-              <a:rPr lang="en-US" sz="1300" b="1" dirty="0">
+              <a:rPr lang="en-US" sz="1250" b="1" dirty="0">
                 <a:solidFill>
                   <a:srgbClr val="FFFFFF"/>
                 </a:solidFill>
@@ -8547,7 +8637,7 @@
               <a:buNone/>
             </a:pPr>
             <a:r>
-              <a:rPr lang="en-US" sz="1300" dirty="0">
+              <a:rPr lang="en-US" sz="1250" dirty="0">
                 <a:solidFill>
                   <a:srgbClr val="98A2C0"/>
                 </a:solidFill>
@@ -8555,9 +8645,9 @@
                 <a:ea typeface="Calibri" pitchFamily="34" charset="-122"/>
                 <a:cs typeface="Calibri" pitchFamily="34" charset="-120"/>
               </a:rPr>
-              <a:t>47°C day</a:t>
+              <a:t>heat · 5.4 days ≥45°C</a:t>
             </a:r>
-            <a:endParaRPr lang="en-US" sz="1300" dirty="0"/>
+            <a:endParaRPr lang="en-US" sz="1250" dirty="0"/>
           </a:p>
         </p:txBody>
       </p:sp>
@@ -8569,8 +8659,8 @@
         </p:nvSpPr>
         <p:spPr>
           <a:xfrm>
-            <a:off x="10561320" y="5266944"/>
-            <a:ext cx="960120" cy="603504"/>
+            <a:off x="10469880" y="5266944"/>
+            <a:ext cx="1051560" cy="603504"/>
           </a:xfrm>
           <a:prstGeom prst="rect">
             <a:avLst/>
@@ -8594,7 +8684,7 @@
                 <a:ea typeface="Cambria" pitchFamily="34" charset="-122"/>
                 <a:cs typeface="Cambria" pitchFamily="34" charset="-120"/>
               </a:rPr>
-              <a:t>₹29/mo</a:t>
+              <a:t>Phase 2</a:t>
             </a:r>
             <a:endParaRPr lang="en-US" sz="1700" dirty="0"/>
           </a:p>
@@ -8633,7 +8723,7 @@
                 <a:ea typeface="Calibri" pitchFamily="34" charset="-122"/>
                 <a:cs typeface="Calibri" pitchFamily="34" charset="-120"/>
               </a:rPr>
-              <a:t>IMD station reports 2000–2024 via NOAA (Mumbai Santacruz, Nagpur, Ahmedabad). Kavach Basic: ₹300 a payout, max 5 days a year, 60% of premiums paid back.</a:t>
+              <a:t>IMD station reports 2000–2024 via NOAA. City prices for Kavach Basic: Mumbai ₹45, Nagpur ₹52, Ahmedabad ₹29 a month (₹300 a payout, max 5 days a year).</a:t>
             </a:r>
             <a:endParaRPr lang="en-US" sz="950" dirty="0"/>
           </a:p>
@@ -10791,7 +10881,7 @@
                 <a:ea typeface="Cambria" pitchFamily="34" charset="-122"/>
                 <a:cs typeface="Cambria" pitchFamily="34" charset="-120"/>
               </a:rPr>
-              <a:t>Three ways it pays.</a:t>
+              <a:t>Riders first. Then everyone.</a:t>
             </a:r>
             <a:endParaRPr lang="en-US" sz="3400" dirty="0"/>
           </a:p>
@@ -10830,7 +10920,7 @@
                 <a:ea typeface="Cambria" pitchFamily="34" charset="-122"/>
                 <a:cs typeface="Cambria" pitchFamily="34" charset="-120"/>
               </a:rPr>
-              <a:t>₹174 Cr</a:t>
+              <a:t>₹12.5 Cr</a:t>
             </a:r>
             <a:endParaRPr lang="en-US" sz="7200" dirty="0"/>
           </a:p>
@@ -10847,7 +10937,7 @@
                 <a:ea typeface="Calibri" pitchFamily="34" charset="-122"/>
                 <a:cs typeface="Calibri" pitchFamily="34" charset="-120"/>
               </a:rPr>
-              <a:t>a year in premiums if 1% of Jio’s 500M users buy Kavach Basic at ₹29 a month</a:t>
+              <a:t>a year from one delivery app covering 50,000 Mumbai riders on Kavach Plus (₹208 a rider a month)</a:t>
             </a:r>
             <a:endParaRPr lang="en-US" sz="7200" dirty="0"/>
           </a:p>
@@ -10886,7 +10976,7 @@
                 <a:ea typeface="Calibri" pitchFamily="34" charset="-122"/>
                 <a:cs typeface="Calibri" pitchFamily="34" charset="-120"/>
               </a:rPr>
-              <a:t>Near-zero cost to acquire (it rides on the recharge) and zero cost to settle (payouts are automatic).</a:t>
+              <a:t>Riders first: one platform deal covers thousands of workers at once. Settlement is automatic, so most of the premium goes back to people.</a:t>
             </a:r>
             <a:endParaRPr lang="en-US" sz="1300" dirty="0"/>
           </a:p>
@@ -10952,7 +11042,7 @@
                 <a:ea typeface="Cambria" pitchFamily="34" charset="-122"/>
                 <a:cs typeface="Cambria" pitchFamily="34" charset="-120"/>
               </a:rPr>
-              <a:t>Kavach Basic</a:t>
+              <a:t>Kavach Plus · first</a:t>
             </a:r>
             <a:endParaRPr lang="en-US" sz="1800" dirty="0"/>
           </a:p>
@@ -10969,7 +11059,7 @@
                 <a:ea typeface="Calibri" pitchFamily="34" charset="-122"/>
                 <a:cs typeface="Calibri" pitchFamily="34" charset="-120"/>
               </a:rPr>
-              <a:t>Individuals add it at recharge. ₹29–52 a month, priced city by city.</a:t>
+              <a:t>Delivery apps buy it for riders: ₹208 a rider a month in Mumbai, any work-stopping day, up to 5 a year.</a:t>
             </a:r>
             <a:endParaRPr lang="en-US" sz="1800" dirty="0"/>
           </a:p>
@@ -11035,7 +11125,7 @@
                 <a:ea typeface="Cambria" pitchFamily="34" charset="-122"/>
                 <a:cs typeface="Cambria" pitchFamily="34" charset="-120"/>
               </a:rPr>
-              <a:t>Kavach Plus</a:t>
+              <a:t>Kavach Basic · phase 3</a:t>
             </a:r>
             <a:endParaRPr lang="en-US" sz="1800" dirty="0"/>
           </a:p>
@@ -11052,7 +11142,7 @@
                 <a:ea typeface="Calibri" pitchFamily="34" charset="-122"/>
                 <a:cs typeface="Calibri" pitchFamily="34" charset="-120"/>
               </a:rPr>
-              <a:t>Delivery apps buy it for riders: ₹208 a rider a month in Mumbai. 50,000 riders ≈ ₹12.5 Cr a year.</a:t>
+              <a:t>Individuals add it at recharge for ₹29–52 a month by city. 1% of Jio’s users = ₹174 Cr a year.</a:t>
             </a:r>
             <a:endParaRPr lang="en-US" sz="1800" dirty="0"/>
           </a:p>
@@ -12568,7 +12658,7 @@
                 <a:ea typeface="Calibri" pitchFamily="34" charset="-122"/>
                 <a:cs typeface="Calibri" pitchFamily="34" charset="-120"/>
               </a:rPr>
-              <a:t>Rain in Vidarbha, heat in Ahmedabad.</a:t>
+              <a:t>Mumbai monsoon: rain, riders, one delivery app.</a:t>
             </a:r>
             <a:endParaRPr lang="en-US" sz="2200" dirty="0"/>
           </a:p>
@@ -12606,7 +12696,7 @@
                 <a:ea typeface="Calibri" pitchFamily="34" charset="-122"/>
                 <a:cs typeface="Calibri" pitchFamily="34" charset="-120"/>
               </a:rPr>
-              <a:t>Link logs for two districts</a:t>
+              <a:t>Jio link logs for Mumbai</a:t>
             </a:r>
             <a:endParaRPr lang="en-US" sz="2200" dirty="0"/>
           </a:p>
@@ -12627,7 +12717,7 @@
                 <a:ea typeface="Calibri" pitchFamily="34" charset="-122"/>
                 <a:cs typeface="Calibri" pitchFamily="34" charset="-120"/>
               </a:rPr>
-              <a:t>One Jio Financial Services insurance partner</a:t>
+              <a:t>One JFS insurance partner and one delivery app</a:t>
             </a:r>
             <a:endParaRPr lang="en-US" sz="2200" dirty="0"/>
           </a:p>
@@ -13237,6 +13327,1563 @@
 <file path=ppt/slides/slide8.xml><?xml version="1.0" encoding="utf-8"?>
 <p:sld xmlns:a="http://schemas.openxmlformats.org/drawingml/2006/main" xmlns:r="http://schemas.openxmlformats.org/officeDocument/2006/relationships" xmlns:p="http://schemas.openxmlformats.org/presentationml/2006/main">
   <p:cSld name="Slide 8">
+    <p:spTree>
+      <p:nvGrpSpPr>
+        <p:cNvPr id="1" name=""/>
+        <p:cNvGrpSpPr/>
+        <p:nvPr/>
+      </p:nvGrpSpPr>
+      <p:grpSpPr>
+        <a:xfrm>
+          <a:off x="0" y="0"/>
+          <a:ext cx="0" cy="0"/>
+          <a:chOff x="0" y="0"/>
+          <a:chExt cx="0" cy="0"/>
+        </a:xfrm>
+      </p:grpSpPr>
+      <p:sp>
+        <p:nvSpPr>
+          <p:cNvPr id="2" name="!!brand"/>
+          <p:cNvSpPr txBox="1"/>
+          <p:nvPr/>
+        </p:nvSpPr>
+        <p:spPr>
+          <a:xfrm>
+            <a:off x="548640" y="292608"/>
+            <a:ext cx="2743200" cy="365760"/>
+          </a:xfrm>
+          <a:prstGeom prst="rect">
+            <a:avLst/>
+          </a:prstGeom>
+          <a:noFill/>
+          <a:ln/>
+        </p:spPr>
+        <p:txBody>
+          <a:bodyPr wrap="square" lIns="0" tIns="0" rIns="0" bIns="0" rtlCol="0" anchor="ctr"/>
+          <a:lstStyle/>
+          <a:p>
+            <a:pPr indent="0" marL="0">
+              <a:buNone/>
+            </a:pPr>
+            <a:r>
+              <a:rPr lang="en-US" sz="1500" b="1" dirty="0">
+                <a:solidFill>
+                  <a:srgbClr val="EEF1F7"/>
+                </a:solidFill>
+                <a:latin typeface="Cambria" pitchFamily="34" charset="0"/>
+                <a:ea typeface="Cambria" pitchFamily="34" charset="-122"/>
+                <a:cs typeface="Cambria" pitchFamily="34" charset="-120"/>
+              </a:rPr>
+              <a:t>JioMausam</a:t>
+            </a:r>
+            <a:endParaRPr lang="en-US" sz="1500" dirty="0"/>
+          </a:p>
+        </p:txBody>
+      </p:sp>
+      <p:pic>
+        <p:nvPicPr>
+          <p:cNvPr id="3" name="!!tower" descr="/tmp/claude-0/-home-user-market-research-agent/e8d4caac-b1a5-588e-8461-832ca62ca567/scratchpad/deck/assets/tower.png">    </p:cNvPr>
+          <p:cNvPicPr>
+            <a:picLocks noChangeAspect="1"/>
+          </p:cNvPicPr>
+          <p:nvPr/>
+        </p:nvPicPr>
+        <p:blipFill>
+          <a:blip r:embed="rId1"/>
+          <a:stretch>
+            <a:fillRect/>
+          </a:stretch>
+        </p:blipFill>
+        <p:spPr>
+          <a:xfrm>
+            <a:off x="11259007" y="201168"/>
+            <a:ext cx="384048" cy="548640"/>
+          </a:xfrm>
+          <a:prstGeom prst="rect">
+            <a:avLst/>
+          </a:prstGeom>
+        </p:spPr>
+      </p:pic>
+      <p:sp>
+        <p:nvSpPr>
+          <p:cNvPr id="4" name="kicker"/>
+          <p:cNvSpPr txBox="1"/>
+          <p:nvPr/>
+        </p:nvSpPr>
+        <p:spPr>
+          <a:xfrm>
+            <a:off x="548640" y="868680"/>
+            <a:ext cx="8229600" cy="274320"/>
+          </a:xfrm>
+          <a:prstGeom prst="rect">
+            <a:avLst/>
+          </a:prstGeom>
+          <a:noFill/>
+          <a:ln/>
+        </p:spPr>
+        <p:txBody>
+          <a:bodyPr wrap="square" lIns="0" tIns="0" rIns="0" bIns="0" rtlCol="0" anchor="ctr"/>
+          <a:lstStyle/>
+          <a:p>
+            <a:pPr indent="0" marL="0">
+              <a:buNone/>
+            </a:pPr>
+            <a:r>
+              <a:rPr lang="en-US" sz="1100" b="1" spc="300" kern="0" dirty="0">
+                <a:solidFill>
+                  <a:srgbClr val="F5A623"/>
+                </a:solidFill>
+                <a:latin typeface="Calibri" pitchFamily="34" charset="0"/>
+                <a:ea typeface="Calibri" pitchFamily="34" charset="-122"/>
+                <a:cs typeface="Calibri" pitchFamily="34" charset="-120"/>
+              </a:rPr>
+              <a:t>THE ROADMAP</a:t>
+            </a:r>
+            <a:endParaRPr lang="en-US" sz="1100" dirty="0"/>
+          </a:p>
+        </p:txBody>
+      </p:sp>
+      <p:sp>
+        <p:nvSpPr>
+          <p:cNvPr id="5" name="title"/>
+          <p:cNvSpPr txBox="1"/>
+          <p:nvPr/>
+        </p:nvSpPr>
+        <p:spPr>
+          <a:xfrm>
+            <a:off x="548640" y="1170432"/>
+            <a:ext cx="10515600" cy="868680"/>
+          </a:xfrm>
+          <a:prstGeom prst="rect">
+            <a:avLst/>
+          </a:prstGeom>
+          <a:noFill/>
+          <a:ln/>
+        </p:spPr>
+        <p:txBody>
+          <a:bodyPr wrap="square" lIns="0" tIns="0" rIns="0" bIns="0" rtlCol="0" anchor="t"/>
+          <a:lstStyle/>
+          <a:p>
+            <a:pPr indent="0" marL="0">
+              <a:buNone/>
+            </a:pPr>
+            <a:r>
+              <a:rPr lang="en-US" sz="3400" b="1" dirty="0">
+                <a:solidFill>
+                  <a:srgbClr val="FFFFFF"/>
+                </a:solidFill>
+                <a:latin typeface="Cambria" pitchFamily="34" charset="0"/>
+                <a:ea typeface="Cambria" pitchFamily="34" charset="-122"/>
+                <a:cs typeface="Cambria" pitchFamily="34" charset="-120"/>
+              </a:rPr>
+              <a:t>Four phases. Rain first.</a:t>
+            </a:r>
+            <a:endParaRPr lang="en-US" sz="3400" dirty="0"/>
+          </a:p>
+        </p:txBody>
+      </p:sp>
+      <p:sp>
+        <p:nvSpPr>
+          <p:cNvPr id="6" name="phB0"/>
+          <p:cNvSpPr/>
+          <p:nvPr/>
+        </p:nvSpPr>
+        <p:spPr>
+          <a:xfrm>
+            <a:off x="548640" y="2240280"/>
+            <a:ext cx="2606040" cy="3383280"/>
+          </a:xfrm>
+          <a:prstGeom prst="roundRect">
+            <a:avLst>
+              <a:gd name="adj" fmla="val 4912"/>
+            </a:avLst>
+          </a:prstGeom>
+          <a:solidFill>
+            <a:srgbClr val="F5A623"/>
+          </a:solidFill>
+          <a:ln w="9525">
+            <a:solidFill>
+              <a:srgbClr val="F5A623"/>
+            </a:solidFill>
+            <a:prstDash val="solid"/>
+          </a:ln>
+        </p:spPr>
+      </p:sp>
+      <p:sp>
+        <p:nvSpPr>
+          <p:cNvPr id="7" name="phT0"/>
+          <p:cNvSpPr txBox="1"/>
+          <p:nvPr/>
+        </p:nvSpPr>
+        <p:spPr>
+          <a:xfrm>
+            <a:off x="777240" y="2377440"/>
+            <a:ext cx="2148840" cy="3108960"/>
+          </a:xfrm>
+          <a:prstGeom prst="rect">
+            <a:avLst/>
+          </a:prstGeom>
+          <a:noFill/>
+          <a:ln/>
+        </p:spPr>
+        <p:txBody>
+          <a:bodyPr wrap="square" lIns="0" tIns="0" rIns="0" bIns="0" rtlCol="0" anchor="t"/>
+          <a:lstStyle/>
+          <a:p>
+            <a:pPr indent="0" marL="0">
+              <a:spcAft>
+                <a:spcPts val="400"/>
+              </a:spcAft>
+              <a:buNone/>
+            </a:pPr>
+            <a:r>
+              <a:rPr lang="en-US" sz="5400" b="1" dirty="0">
+                <a:solidFill>
+                  <a:srgbClr val="1A1200"/>
+                </a:solidFill>
+                <a:latin typeface="Cambria" pitchFamily="34" charset="0"/>
+                <a:ea typeface="Cambria" pitchFamily="34" charset="-122"/>
+                <a:cs typeface="Cambria" pitchFamily="34" charset="-120"/>
+              </a:rPr>
+              <a:t>1</a:t>
+            </a:r>
+            <a:endParaRPr lang="en-US" sz="5400" dirty="0"/>
+          </a:p>
+          <a:p>
+            <a:pPr indent="0" marL="0">
+              <a:spcAft>
+                <a:spcPts val="400"/>
+              </a:spcAft>
+              <a:buNone/>
+            </a:pPr>
+            <a:r>
+              <a:rPr lang="en-US" sz="1050" b="1" spc="200" kern="0" dirty="0">
+                <a:solidFill>
+                  <a:srgbClr val="3A2A00"/>
+                </a:solidFill>
+                <a:latin typeface="Calibri" pitchFamily="34" charset="0"/>
+                <a:ea typeface="Calibri" pitchFamily="34" charset="-122"/>
+                <a:cs typeface="Calibri" pitchFamily="34" charset="-120"/>
+              </a:rPr>
+              <a:t>MONTHS 0–3</a:t>
+            </a:r>
+            <a:endParaRPr lang="en-US" sz="5400" dirty="0"/>
+          </a:p>
+          <a:p>
+            <a:pPr indent="0" marL="0">
+              <a:spcAft>
+                <a:spcPts val="400"/>
+              </a:spcAft>
+              <a:buNone/>
+            </a:pPr>
+            <a:r>
+              <a:rPr lang="en-US" sz="1900" b="1" dirty="0">
+                <a:solidFill>
+                  <a:srgbClr val="1A1200"/>
+                </a:solidFill>
+                <a:latin typeface="Cambria" pitchFamily="34" charset="0"/>
+                <a:ea typeface="Cambria" pitchFamily="34" charset="-122"/>
+                <a:cs typeface="Cambria" pitchFamily="34" charset="-120"/>
+              </a:rPr>
+              <a:t>Mumbai monsoon pilot</a:t>
+            </a:r>
+            <a:endParaRPr lang="en-US" sz="5400" dirty="0"/>
+          </a:p>
+          <a:p>
+            <a:pPr indent="0" marL="0">
+              <a:spcAft>
+                <a:spcPts val="400"/>
+              </a:spcAft>
+              <a:buNone/>
+            </a:pPr>
+            <a:r>
+              <a:rPr lang="en-US" sz="1300" dirty="0">
+                <a:solidFill>
+                  <a:srgbClr val="2A1E00"/>
+                </a:solidFill>
+                <a:latin typeface="Calibri" pitchFamily="34" charset="0"/>
+                <a:ea typeface="Calibri" pitchFamily="34" charset="-122"/>
+                <a:cs typeface="Calibri" pitchFamily="34" charset="-120"/>
+              </a:rPr>
+              <a:t>Rain, riders, one delivery app. Measure link coverage and accuracy against IMD.</a:t>
+            </a:r>
+            <a:endParaRPr lang="en-US" sz="5400" dirty="0"/>
+          </a:p>
+        </p:txBody>
+      </p:sp>
+      <p:sp>
+        <p:nvSpPr>
+          <p:cNvPr id="8" name="phB1"/>
+          <p:cNvSpPr/>
+          <p:nvPr/>
+        </p:nvSpPr>
+        <p:spPr>
+          <a:xfrm>
+            <a:off x="3346704" y="2240280"/>
+            <a:ext cx="2606040" cy="3383280"/>
+          </a:xfrm>
+          <a:prstGeom prst="roundRect">
+            <a:avLst>
+              <a:gd name="adj" fmla="val 4912"/>
+            </a:avLst>
+          </a:prstGeom>
+          <a:solidFill>
+            <a:srgbClr val="141B36"/>
+          </a:solidFill>
+          <a:ln w="9525">
+            <a:solidFill>
+              <a:srgbClr val="2A3357"/>
+            </a:solidFill>
+            <a:prstDash val="solid"/>
+          </a:ln>
+        </p:spPr>
+      </p:sp>
+      <p:sp>
+        <p:nvSpPr>
+          <p:cNvPr id="9" name="phT1"/>
+          <p:cNvSpPr txBox="1"/>
+          <p:nvPr/>
+        </p:nvSpPr>
+        <p:spPr>
+          <a:xfrm>
+            <a:off x="3575304" y="2377440"/>
+            <a:ext cx="2148840" cy="3108960"/>
+          </a:xfrm>
+          <a:prstGeom prst="rect">
+            <a:avLst/>
+          </a:prstGeom>
+          <a:noFill/>
+          <a:ln/>
+        </p:spPr>
+        <p:txBody>
+          <a:bodyPr wrap="square" lIns="0" tIns="0" rIns="0" bIns="0" rtlCol="0" anchor="t"/>
+          <a:lstStyle/>
+          <a:p>
+            <a:pPr indent="0" marL="0">
+              <a:spcAft>
+                <a:spcPts val="400"/>
+              </a:spcAft>
+              <a:buNone/>
+            </a:pPr>
+            <a:r>
+              <a:rPr lang="en-US" sz="5400" b="1" dirty="0">
+                <a:solidFill>
+                  <a:srgbClr val="F5A623"/>
+                </a:solidFill>
+                <a:latin typeface="Cambria" pitchFamily="34" charset="0"/>
+                <a:ea typeface="Cambria" pitchFamily="34" charset="-122"/>
+                <a:cs typeface="Cambria" pitchFamily="34" charset="-120"/>
+              </a:rPr>
+              <a:t>2</a:t>
+            </a:r>
+            <a:endParaRPr lang="en-US" sz="5400" dirty="0"/>
+          </a:p>
+          <a:p>
+            <a:pPr indent="0" marL="0">
+              <a:spcAft>
+                <a:spcPts val="400"/>
+              </a:spcAft>
+              <a:buNone/>
+            </a:pPr>
+            <a:r>
+              <a:rPr lang="en-US" sz="1050" b="1" spc="200" kern="0" dirty="0">
+                <a:solidFill>
+                  <a:srgbClr val="98A2C0"/>
+                </a:solidFill>
+                <a:latin typeface="Calibri" pitchFamily="34" charset="0"/>
+                <a:ea typeface="Calibri" pitchFamily="34" charset="-122"/>
+                <a:cs typeface="Calibri" pitchFamily="34" charset="-120"/>
+              </a:rPr>
+              <a:t>MONTHS 4–12</a:t>
+            </a:r>
+            <a:endParaRPr lang="en-US" sz="5400" dirty="0"/>
+          </a:p>
+          <a:p>
+            <a:pPr indent="0" marL="0">
+              <a:spcAft>
+                <a:spcPts val="400"/>
+              </a:spcAft>
+              <a:buNone/>
+            </a:pPr>
+            <a:r>
+              <a:rPr lang="en-US" sz="1900" b="1" dirty="0">
+                <a:solidFill>
+                  <a:srgbClr val="FFFFFF"/>
+                </a:solidFill>
+                <a:latin typeface="Cambria" pitchFamily="34" charset="0"/>
+                <a:ea typeface="Cambria" pitchFamily="34" charset="-122"/>
+                <a:cs typeface="Cambria" pitchFamily="34" charset="-120"/>
+              </a:rPr>
+              <a:t>Heatwaves</a:t>
+            </a:r>
+            <a:endParaRPr lang="en-US" sz="5400" dirty="0"/>
+          </a:p>
+          <a:p>
+            <a:pPr indent="0" marL="0">
+              <a:spcAft>
+                <a:spcPts val="400"/>
+              </a:spcAft>
+              <a:buNone/>
+            </a:pPr>
+            <a:r>
+              <a:rPr lang="en-US" sz="1300" dirty="0">
+                <a:solidFill>
+                  <a:srgbClr val="B9C2D8"/>
+                </a:solidFill>
+                <a:latin typeface="Calibri" pitchFamily="34" charset="0"/>
+                <a:ea typeface="Calibri" pitchFamily="34" charset="-122"/>
+                <a:cs typeface="Calibri" pitchFamily="34" charset="-120"/>
+              </a:rPr>
+              <a:t>Nagpur and Ahmedabad. Heat from phone and tower-site sensors.</a:t>
+            </a:r>
+            <a:endParaRPr lang="en-US" sz="5400" dirty="0"/>
+          </a:p>
+        </p:txBody>
+      </p:sp>
+      <p:sp>
+        <p:nvSpPr>
+          <p:cNvPr id="10" name="phB2"/>
+          <p:cNvSpPr/>
+          <p:nvPr/>
+        </p:nvSpPr>
+        <p:spPr>
+          <a:xfrm>
+            <a:off x="6144768" y="2240280"/>
+            <a:ext cx="2606040" cy="3383280"/>
+          </a:xfrm>
+          <a:prstGeom prst="roundRect">
+            <a:avLst>
+              <a:gd name="adj" fmla="val 4912"/>
+            </a:avLst>
+          </a:prstGeom>
+          <a:solidFill>
+            <a:srgbClr val="141B36"/>
+          </a:solidFill>
+          <a:ln w="9525">
+            <a:solidFill>
+              <a:srgbClr val="2A3357"/>
+            </a:solidFill>
+            <a:prstDash val="solid"/>
+          </a:ln>
+        </p:spPr>
+      </p:sp>
+      <p:sp>
+        <p:nvSpPr>
+          <p:cNvPr id="11" name="phT2"/>
+          <p:cNvSpPr txBox="1"/>
+          <p:nvPr/>
+        </p:nvSpPr>
+        <p:spPr>
+          <a:xfrm>
+            <a:off x="6373368" y="2377440"/>
+            <a:ext cx="2148840" cy="3108960"/>
+          </a:xfrm>
+          <a:prstGeom prst="rect">
+            <a:avLst/>
+          </a:prstGeom>
+          <a:noFill/>
+          <a:ln/>
+        </p:spPr>
+        <p:txBody>
+          <a:bodyPr wrap="square" lIns="0" tIns="0" rIns="0" bIns="0" rtlCol="0" anchor="t"/>
+          <a:lstStyle/>
+          <a:p>
+            <a:pPr indent="0" marL="0">
+              <a:spcAft>
+                <a:spcPts val="400"/>
+              </a:spcAft>
+              <a:buNone/>
+            </a:pPr>
+            <a:r>
+              <a:rPr lang="en-US" sz="5400" b="1" dirty="0">
+                <a:solidFill>
+                  <a:srgbClr val="F5A623"/>
+                </a:solidFill>
+                <a:latin typeface="Cambria" pitchFamily="34" charset="0"/>
+                <a:ea typeface="Cambria" pitchFamily="34" charset="-122"/>
+                <a:cs typeface="Cambria" pitchFamily="34" charset="-120"/>
+              </a:rPr>
+              <a:t>3</a:t>
+            </a:r>
+            <a:endParaRPr lang="en-US" sz="5400" dirty="0"/>
+          </a:p>
+          <a:p>
+            <a:pPr indent="0" marL="0">
+              <a:spcAft>
+                <a:spcPts val="400"/>
+              </a:spcAft>
+              <a:buNone/>
+            </a:pPr>
+            <a:r>
+              <a:rPr lang="en-US" sz="1050" b="1" spc="200" kern="0" dirty="0">
+                <a:solidFill>
+                  <a:srgbClr val="98A2C0"/>
+                </a:solidFill>
+                <a:latin typeface="Calibri" pitchFamily="34" charset="0"/>
+                <a:ea typeface="Calibri" pitchFamily="34" charset="-122"/>
+                <a:cs typeface="Calibri" pitchFamily="34" charset="-120"/>
+              </a:rPr>
+              <a:t>YEAR 2</a:t>
+            </a:r>
+            <a:endParaRPr lang="en-US" sz="5400" dirty="0"/>
+          </a:p>
+          <a:p>
+            <a:pPr indent="0" marL="0">
+              <a:spcAft>
+                <a:spcPts val="400"/>
+              </a:spcAft>
+              <a:buNone/>
+            </a:pPr>
+            <a:r>
+              <a:rPr lang="en-US" sz="1900" b="1" dirty="0">
+                <a:solidFill>
+                  <a:srgbClr val="FFFFFF"/>
+                </a:solidFill>
+                <a:latin typeface="Cambria" pitchFamily="34" charset="0"/>
+                <a:ea typeface="Cambria" pitchFamily="34" charset="-122"/>
+                <a:cs typeface="Cambria" pitchFamily="34" charset="-120"/>
+              </a:rPr>
+              <a:t>Kavach Basic</a:t>
+            </a:r>
+            <a:endParaRPr lang="en-US" sz="5400" dirty="0"/>
+          </a:p>
+          <a:p>
+            <a:pPr indent="0" marL="0">
+              <a:spcAft>
+                <a:spcPts val="400"/>
+              </a:spcAft>
+              <a:buNone/>
+            </a:pPr>
+            <a:r>
+              <a:rPr lang="en-US" sz="1300" dirty="0">
+                <a:solidFill>
+                  <a:srgbClr val="B9C2D8"/>
+                </a:solidFill>
+                <a:latin typeface="Calibri" pitchFamily="34" charset="0"/>
+                <a:ea typeface="Calibri" pitchFamily="34" charset="-122"/>
+                <a:cs typeface="Calibri" pitchFamily="34" charset="-120"/>
+              </a:rPr>
+              <a:t>At every recharge, priced city by city: ₹29–52 a month.</a:t>
+            </a:r>
+            <a:endParaRPr lang="en-US" sz="5400" dirty="0"/>
+          </a:p>
+        </p:txBody>
+      </p:sp>
+      <p:sp>
+        <p:nvSpPr>
+          <p:cNvPr id="12" name="phB3"/>
+          <p:cNvSpPr/>
+          <p:nvPr/>
+        </p:nvSpPr>
+        <p:spPr>
+          <a:xfrm>
+            <a:off x="8942832" y="2240280"/>
+            <a:ext cx="2606040" cy="3383280"/>
+          </a:xfrm>
+          <a:prstGeom prst="roundRect">
+            <a:avLst>
+              <a:gd name="adj" fmla="val 4912"/>
+            </a:avLst>
+          </a:prstGeom>
+          <a:solidFill>
+            <a:srgbClr val="141B36"/>
+          </a:solidFill>
+          <a:ln w="9525">
+            <a:solidFill>
+              <a:srgbClr val="2A3357"/>
+            </a:solidFill>
+            <a:prstDash val="solid"/>
+          </a:ln>
+        </p:spPr>
+      </p:sp>
+      <p:sp>
+        <p:nvSpPr>
+          <p:cNvPr id="13" name="phT3"/>
+          <p:cNvSpPr txBox="1"/>
+          <p:nvPr/>
+        </p:nvSpPr>
+        <p:spPr>
+          <a:xfrm>
+            <a:off x="9171432" y="2377440"/>
+            <a:ext cx="2148840" cy="3108960"/>
+          </a:xfrm>
+          <a:prstGeom prst="rect">
+            <a:avLst/>
+          </a:prstGeom>
+          <a:noFill/>
+          <a:ln/>
+        </p:spPr>
+        <p:txBody>
+          <a:bodyPr wrap="square" lIns="0" tIns="0" rIns="0" bIns="0" rtlCol="0" anchor="t"/>
+          <a:lstStyle/>
+          <a:p>
+            <a:pPr indent="0" marL="0">
+              <a:spcAft>
+                <a:spcPts val="400"/>
+              </a:spcAft>
+              <a:buNone/>
+            </a:pPr>
+            <a:r>
+              <a:rPr lang="en-US" sz="5400" b="1" dirty="0">
+                <a:solidFill>
+                  <a:srgbClr val="F5A623"/>
+                </a:solidFill>
+                <a:latin typeface="Cambria" pitchFamily="34" charset="0"/>
+                <a:ea typeface="Cambria" pitchFamily="34" charset="-122"/>
+                <a:cs typeface="Cambria" pitchFamily="34" charset="-120"/>
+              </a:rPr>
+              <a:t>4</a:t>
+            </a:r>
+            <a:endParaRPr lang="en-US" sz="5400" dirty="0"/>
+          </a:p>
+          <a:p>
+            <a:pPr indent="0" marL="0">
+              <a:spcAft>
+                <a:spcPts val="400"/>
+              </a:spcAft>
+              <a:buNone/>
+            </a:pPr>
+            <a:r>
+              <a:rPr lang="en-US" sz="1050" b="1" spc="200" kern="0" dirty="0">
+                <a:solidFill>
+                  <a:srgbClr val="98A2C0"/>
+                </a:solidFill>
+                <a:latin typeface="Calibri" pitchFamily="34" charset="0"/>
+                <a:ea typeface="Calibri" pitchFamily="34" charset="-122"/>
+                <a:cs typeface="Calibri" pitchFamily="34" charset="-120"/>
+              </a:rPr>
+              <a:t>YEAR 3</a:t>
+            </a:r>
+            <a:endParaRPr lang="en-US" sz="5400" dirty="0"/>
+          </a:p>
+          <a:p>
+            <a:pPr indent="0" marL="0">
+              <a:spcAft>
+                <a:spcPts val="400"/>
+              </a:spcAft>
+              <a:buNone/>
+            </a:pPr>
+            <a:r>
+              <a:rPr lang="en-US" sz="1900" b="1" dirty="0">
+                <a:solidFill>
+                  <a:srgbClr val="FFFFFF"/>
+                </a:solidFill>
+                <a:latin typeface="Cambria" pitchFamily="34" charset="0"/>
+                <a:ea typeface="Cambria" pitchFamily="34" charset="-122"/>
+                <a:cs typeface="Cambria" pitchFamily="34" charset="-120"/>
+              </a:rPr>
+              <a:t>National map</a:t>
+            </a:r>
+            <a:endParaRPr lang="en-US" sz="5400" dirty="0"/>
+          </a:p>
+          <a:p>
+            <a:pPr indent="0" marL="0">
+              <a:spcAft>
+                <a:spcPts val="400"/>
+              </a:spcAft>
+              <a:buNone/>
+            </a:pPr>
+            <a:r>
+              <a:rPr lang="en-US" sz="1300" dirty="0">
+                <a:solidFill>
+                  <a:srgbClr val="B9C2D8"/>
+                </a:solidFill>
+                <a:latin typeface="Calibri" pitchFamily="34" charset="0"/>
+                <a:ea typeface="Calibri" pitchFamily="34" charset="-122"/>
+                <a:cs typeface="Calibri" pitchFamily="34" charset="-120"/>
+              </a:rPr>
+              <a:t>Every district. Data API for insurers, states and Reliance.</a:t>
+            </a:r>
+            <a:endParaRPr lang="en-US" sz="5400" dirty="0"/>
+          </a:p>
+        </p:txBody>
+      </p:sp>
+    </p:spTree>
+  </p:cSld>
+  <p:clrMapOvr>
+    <a:masterClrMapping/>
+  </p:clrMapOvr>
+  <mc:AlternateContent xmlns:mc="http://schemas.openxmlformats.org/markup-compatibility/2006">
+    <mc:Choice xmlns:p159="http://schemas.microsoft.com/office/powerpoint/2015/09/main" Requires="p159">
+      <p:transition spd="slow">
+        <p159:morph option="byObject"/>
+      </p:transition>
+    </mc:Choice>
+    <mc:Fallback>
+      <p:transition spd="slow">
+        <p:fade/>
+      </p:transition>
+    </mc:Fallback>
+  </mc:AlternateContent>
+  <p:timing>
+    <p:tnLst>
+      <p:par>
+        <p:cTn id="1" dur="indefinite" restart="never" nodeType="tmRoot">
+          <p:childTnLst>
+            <p:seq concurrent="1" nextAc="seek">
+              <p:cTn id="2" dur="indefinite" nodeType="mainSeq">
+                <p:childTnLst>
+                  <p:par>
+                    <p:cTn id="56" fill="hold">
+                      <p:stCondLst>
+                        <p:cond delay="indefinite"/>
+                        <p:cond evt="onBegin" delay="0">
+                          <p:tn val="2"/>
+                        </p:cond>
+                      </p:stCondLst>
+                      <p:childTnLst>
+                        <p:par>
+                          <p:cTn id="3" fill="hold">
+                            <p:stCondLst>
+                              <p:cond delay="0"/>
+                            </p:stCondLst>
+                            <p:childTnLst>
+                              <p:par>
+                                <p:cTn id="4" presetID="10" presetClass="entr" presetSubtype="0" fill="hold" grpId="0" nodeType="afterEffect">
+                                  <p:stCondLst>
+                                    <p:cond delay="0"/>
+                                  </p:stCondLst>
+                                  <p:childTnLst>
+                                    <p:set>
+                                      <p:cBhvr>
+                                        <p:cTn id="5" dur="1" fill="hold">
+                                          <p:stCondLst>
+                                            <p:cond delay="0"/>
+                                          </p:stCondLst>
+                                        </p:cTn>
+                                        <p:tgtEl>
+                                          <p:spTgt spid="4"/>
+                                        </p:tgtEl>
+                                        <p:attrNameLst>
+                                          <p:attrName>style.visibility</p:attrName>
+                                        </p:attrNameLst>
+                                      </p:cBhvr>
+                                      <p:to>
+                                        <p:strVal val="visible"/>
+                                      </p:to>
+                                    </p:set>
+                                    <p:animEffect transition="in" filter="fade">
+                                      <p:cBhvr>
+                                        <p:cTn id="6" dur="500"/>
+                                        <p:tgtEl>
+                                          <p:spTgt spid="4"/>
+                                        </p:tgtEl>
+                                      </p:cBhvr>
+                                    </p:animEffect>
+                                  </p:childTnLst>
+                                </p:cTn>
+                              </p:par>
+                              <p:par>
+                                <p:cTn id="7" presetID="42" presetClass="entr" presetSubtype="0" fill="hold" grpId="0" nodeType="withEffect">
+                                  <p:stCondLst>
+                                    <p:cond delay="120"/>
+                                  </p:stCondLst>
+                                  <p:childTnLst>
+                                    <p:set>
+                                      <p:cBhvr>
+                                        <p:cTn id="8" dur="1" fill="hold">
+                                          <p:stCondLst>
+                                            <p:cond delay="0"/>
+                                          </p:stCondLst>
+                                        </p:cTn>
+                                        <p:tgtEl>
+                                          <p:spTgt spid="5"/>
+                                        </p:tgtEl>
+                                        <p:attrNameLst>
+                                          <p:attrName>style.visibility</p:attrName>
+                                        </p:attrNameLst>
+                                      </p:cBhvr>
+                                      <p:to>
+                                        <p:strVal val="visible"/>
+                                      </p:to>
+                                    </p:set>
+                                    <p:animEffect transition="in" filter="fade">
+                                      <p:cBhvr>
+                                        <p:cTn id="9" dur="800"/>
+                                        <p:tgtEl>
+                                          <p:spTgt spid="5"/>
+                                        </p:tgtEl>
+                                      </p:cBhvr>
+                                    </p:animEffect>
+                                    <p:anim calcmode="lin" valueType="num">
+                                      <p:cBhvr>
+                                        <p:cTn id="10" dur="800" fill="hold"/>
+                                        <p:tgtEl>
+                                          <p:spTgt spid="5"/>
+                                        </p:tgtEl>
+                                        <p:attrNameLst>
+                                          <p:attrName>ppt_x</p:attrName>
+                                        </p:attrNameLst>
+                                      </p:cBhvr>
+                                      <p:tavLst>
+                                        <p:tav tm="0">
+                                          <p:val>
+                                            <p:strVal val="#ppt_x"/>
+                                          </p:val>
+                                        </p:tav>
+                                        <p:tav tm="100000">
+                                          <p:val>
+                                            <p:strVal val="#ppt_x"/>
+                                          </p:val>
+                                        </p:tav>
+                                      </p:tavLst>
+                                    </p:anim>
+                                    <p:anim calcmode="lin" valueType="num">
+                                      <p:cBhvr>
+                                        <p:cTn id="11" dur="800" fill="hold"/>
+                                        <p:tgtEl>
+                                          <p:spTgt spid="5"/>
+                                        </p:tgtEl>
+                                        <p:attrNameLst>
+                                          <p:attrName>ppt_y</p:attrName>
+                                        </p:attrNameLst>
+                                      </p:cBhvr>
+                                      <p:tavLst>
+                                        <p:tav tm="0">
+                                          <p:val>
+                                            <p:strVal val="#ppt_y+.06"/>
+                                          </p:val>
+                                        </p:tav>
+                                        <p:tav tm="100000">
+                                          <p:val>
+                                            <p:strVal val="#ppt_y"/>
+                                          </p:val>
+                                        </p:tav>
+                                      </p:tavLst>
+                                    </p:anim>
+                                  </p:childTnLst>
+                                </p:cTn>
+                              </p:par>
+                            </p:childTnLst>
+                          </p:cTn>
+                        </p:par>
+                        <p:par>
+                          <p:cTn id="12" fill="hold">
+                            <p:stCondLst>
+                              <p:cond delay="920"/>
+                            </p:stCondLst>
+                            <p:childTnLst>
+                              <p:par>
+                                <p:cTn id="13" presetID="42" presetClass="entr" presetSubtype="0" fill="hold" grpId="0" nodeType="afterEffect">
+                                  <p:stCondLst>
+                                    <p:cond delay="80"/>
+                                  </p:stCondLst>
+                                  <p:childTnLst>
+                                    <p:set>
+                                      <p:cBhvr>
+                                        <p:cTn id="14" dur="1" fill="hold">
+                                          <p:stCondLst>
+                                            <p:cond delay="0"/>
+                                          </p:stCondLst>
+                                        </p:cTn>
+                                        <p:tgtEl>
+                                          <p:spTgt spid="6"/>
+                                        </p:tgtEl>
+                                        <p:attrNameLst>
+                                          <p:attrName>style.visibility</p:attrName>
+                                        </p:attrNameLst>
+                                      </p:cBhvr>
+                                      <p:to>
+                                        <p:strVal val="visible"/>
+                                      </p:to>
+                                    </p:set>
+                                    <p:animEffect transition="in" filter="fade">
+                                      <p:cBhvr>
+                                        <p:cTn id="15" dur="600"/>
+                                        <p:tgtEl>
+                                          <p:spTgt spid="6"/>
+                                        </p:tgtEl>
+                                      </p:cBhvr>
+                                    </p:animEffect>
+                                    <p:anim calcmode="lin" valueType="num">
+                                      <p:cBhvr>
+                                        <p:cTn id="16" dur="600" fill="hold"/>
+                                        <p:tgtEl>
+                                          <p:spTgt spid="6"/>
+                                        </p:tgtEl>
+                                        <p:attrNameLst>
+                                          <p:attrName>ppt_x</p:attrName>
+                                        </p:attrNameLst>
+                                      </p:cBhvr>
+                                      <p:tavLst>
+                                        <p:tav tm="0">
+                                          <p:val>
+                                            <p:strVal val="#ppt_x"/>
+                                          </p:val>
+                                        </p:tav>
+                                        <p:tav tm="100000">
+                                          <p:val>
+                                            <p:strVal val="#ppt_x"/>
+                                          </p:val>
+                                        </p:tav>
+                                      </p:tavLst>
+                                    </p:anim>
+                                    <p:anim calcmode="lin" valueType="num">
+                                      <p:cBhvr>
+                                        <p:cTn id="17" dur="600" fill="hold"/>
+                                        <p:tgtEl>
+                                          <p:spTgt spid="6"/>
+                                        </p:tgtEl>
+                                        <p:attrNameLst>
+                                          <p:attrName>ppt_y</p:attrName>
+                                        </p:attrNameLst>
+                                      </p:cBhvr>
+                                      <p:tavLst>
+                                        <p:tav tm="0">
+                                          <p:val>
+                                            <p:strVal val="#ppt_y+.06"/>
+                                          </p:val>
+                                        </p:tav>
+                                        <p:tav tm="100000">
+                                          <p:val>
+                                            <p:strVal val="#ppt_y"/>
+                                          </p:val>
+                                        </p:tav>
+                                      </p:tavLst>
+                                    </p:anim>
+                                  </p:childTnLst>
+                                </p:cTn>
+                              </p:par>
+                              <p:par>
+                                <p:cTn id="18" presetID="42" presetClass="entr" presetSubtype="0" fill="hold" grpId="0" nodeType="withEffect">
+                                  <p:stCondLst>
+                                    <p:cond delay="0"/>
+                                  </p:stCondLst>
+                                  <p:childTnLst>
+                                    <p:set>
+                                      <p:cBhvr>
+                                        <p:cTn id="19" dur="1" fill="hold">
+                                          <p:stCondLst>
+                                            <p:cond delay="0"/>
+                                          </p:stCondLst>
+                                        </p:cTn>
+                                        <p:tgtEl>
+                                          <p:spTgt spid="7"/>
+                                        </p:tgtEl>
+                                        <p:attrNameLst>
+                                          <p:attrName>style.visibility</p:attrName>
+                                        </p:attrNameLst>
+                                      </p:cBhvr>
+                                      <p:to>
+                                        <p:strVal val="visible"/>
+                                      </p:to>
+                                    </p:set>
+                                    <p:animEffect transition="in" filter="fade">
+                                      <p:cBhvr>
+                                        <p:cTn id="20" dur="600"/>
+                                        <p:tgtEl>
+                                          <p:spTgt spid="7"/>
+                                        </p:tgtEl>
+                                      </p:cBhvr>
+                                    </p:animEffect>
+                                    <p:anim calcmode="lin" valueType="num">
+                                      <p:cBhvr>
+                                        <p:cTn id="21" dur="600" fill="hold"/>
+                                        <p:tgtEl>
+                                          <p:spTgt spid="7"/>
+                                        </p:tgtEl>
+                                        <p:attrNameLst>
+                                          <p:attrName>ppt_x</p:attrName>
+                                        </p:attrNameLst>
+                                      </p:cBhvr>
+                                      <p:tavLst>
+                                        <p:tav tm="0">
+                                          <p:val>
+                                            <p:strVal val="#ppt_x"/>
+                                          </p:val>
+                                        </p:tav>
+                                        <p:tav tm="100000">
+                                          <p:val>
+                                            <p:strVal val="#ppt_x"/>
+                                          </p:val>
+                                        </p:tav>
+                                      </p:tavLst>
+                                    </p:anim>
+                                    <p:anim calcmode="lin" valueType="num">
+                                      <p:cBhvr>
+                                        <p:cTn id="22" dur="600" fill="hold"/>
+                                        <p:tgtEl>
+                                          <p:spTgt spid="7"/>
+                                        </p:tgtEl>
+                                        <p:attrNameLst>
+                                          <p:attrName>ppt_y</p:attrName>
+                                        </p:attrNameLst>
+                                      </p:cBhvr>
+                                      <p:tavLst>
+                                        <p:tav tm="0">
+                                          <p:val>
+                                            <p:strVal val="#ppt_y+.06"/>
+                                          </p:val>
+                                        </p:tav>
+                                        <p:tav tm="100000">
+                                          <p:val>
+                                            <p:strVal val="#ppt_y"/>
+                                          </p:val>
+                                        </p:tav>
+                                      </p:tavLst>
+                                    </p:anim>
+                                  </p:childTnLst>
+                                </p:cTn>
+                              </p:par>
+                            </p:childTnLst>
+                          </p:cTn>
+                        </p:par>
+                        <p:par>
+                          <p:cTn id="23" fill="hold">
+                            <p:stCondLst>
+                              <p:cond delay="1600"/>
+                            </p:stCondLst>
+                            <p:childTnLst>
+                              <p:par>
+                                <p:cTn id="24" presetID="42" presetClass="entr" presetSubtype="0" fill="hold" grpId="0" nodeType="afterEffect">
+                                  <p:stCondLst>
+                                    <p:cond delay="80"/>
+                                  </p:stCondLst>
+                                  <p:childTnLst>
+                                    <p:set>
+                                      <p:cBhvr>
+                                        <p:cTn id="25" dur="1" fill="hold">
+                                          <p:stCondLst>
+                                            <p:cond delay="0"/>
+                                          </p:stCondLst>
+                                        </p:cTn>
+                                        <p:tgtEl>
+                                          <p:spTgt spid="8"/>
+                                        </p:tgtEl>
+                                        <p:attrNameLst>
+                                          <p:attrName>style.visibility</p:attrName>
+                                        </p:attrNameLst>
+                                      </p:cBhvr>
+                                      <p:to>
+                                        <p:strVal val="visible"/>
+                                      </p:to>
+                                    </p:set>
+                                    <p:animEffect transition="in" filter="fade">
+                                      <p:cBhvr>
+                                        <p:cTn id="26" dur="600"/>
+                                        <p:tgtEl>
+                                          <p:spTgt spid="8"/>
+                                        </p:tgtEl>
+                                      </p:cBhvr>
+                                    </p:animEffect>
+                                    <p:anim calcmode="lin" valueType="num">
+                                      <p:cBhvr>
+                                        <p:cTn id="27" dur="600" fill="hold"/>
+                                        <p:tgtEl>
+                                          <p:spTgt spid="8"/>
+                                        </p:tgtEl>
+                                        <p:attrNameLst>
+                                          <p:attrName>ppt_x</p:attrName>
+                                        </p:attrNameLst>
+                                      </p:cBhvr>
+                                      <p:tavLst>
+                                        <p:tav tm="0">
+                                          <p:val>
+                                            <p:strVal val="#ppt_x"/>
+                                          </p:val>
+                                        </p:tav>
+                                        <p:tav tm="100000">
+                                          <p:val>
+                                            <p:strVal val="#ppt_x"/>
+                                          </p:val>
+                                        </p:tav>
+                                      </p:tavLst>
+                                    </p:anim>
+                                    <p:anim calcmode="lin" valueType="num">
+                                      <p:cBhvr>
+                                        <p:cTn id="28" dur="600" fill="hold"/>
+                                        <p:tgtEl>
+                                          <p:spTgt spid="8"/>
+                                        </p:tgtEl>
+                                        <p:attrNameLst>
+                                          <p:attrName>ppt_y</p:attrName>
+                                        </p:attrNameLst>
+                                      </p:cBhvr>
+                                      <p:tavLst>
+                                        <p:tav tm="0">
+                                          <p:val>
+                                            <p:strVal val="#ppt_y+.06"/>
+                                          </p:val>
+                                        </p:tav>
+                                        <p:tav tm="100000">
+                                          <p:val>
+                                            <p:strVal val="#ppt_y"/>
+                                          </p:val>
+                                        </p:tav>
+                                      </p:tavLst>
+                                    </p:anim>
+                                  </p:childTnLst>
+                                </p:cTn>
+                              </p:par>
+                              <p:par>
+                                <p:cTn id="29" presetID="42" presetClass="entr" presetSubtype="0" fill="hold" grpId="0" nodeType="withEffect">
+                                  <p:stCondLst>
+                                    <p:cond delay="0"/>
+                                  </p:stCondLst>
+                                  <p:childTnLst>
+                                    <p:set>
+                                      <p:cBhvr>
+                                        <p:cTn id="30" dur="1" fill="hold">
+                                          <p:stCondLst>
+                                            <p:cond delay="0"/>
+                                          </p:stCondLst>
+                                        </p:cTn>
+                                        <p:tgtEl>
+                                          <p:spTgt spid="9"/>
+                                        </p:tgtEl>
+                                        <p:attrNameLst>
+                                          <p:attrName>style.visibility</p:attrName>
+                                        </p:attrNameLst>
+                                      </p:cBhvr>
+                                      <p:to>
+                                        <p:strVal val="visible"/>
+                                      </p:to>
+                                    </p:set>
+                                    <p:animEffect transition="in" filter="fade">
+                                      <p:cBhvr>
+                                        <p:cTn id="31" dur="600"/>
+                                        <p:tgtEl>
+                                          <p:spTgt spid="9"/>
+                                        </p:tgtEl>
+                                      </p:cBhvr>
+                                    </p:animEffect>
+                                    <p:anim calcmode="lin" valueType="num">
+                                      <p:cBhvr>
+                                        <p:cTn id="32" dur="600" fill="hold"/>
+                                        <p:tgtEl>
+                                          <p:spTgt spid="9"/>
+                                        </p:tgtEl>
+                                        <p:attrNameLst>
+                                          <p:attrName>ppt_x</p:attrName>
+                                        </p:attrNameLst>
+                                      </p:cBhvr>
+                                      <p:tavLst>
+                                        <p:tav tm="0">
+                                          <p:val>
+                                            <p:strVal val="#ppt_x"/>
+                                          </p:val>
+                                        </p:tav>
+                                        <p:tav tm="100000">
+                                          <p:val>
+                                            <p:strVal val="#ppt_x"/>
+                                          </p:val>
+                                        </p:tav>
+                                      </p:tavLst>
+                                    </p:anim>
+                                    <p:anim calcmode="lin" valueType="num">
+                                      <p:cBhvr>
+                                        <p:cTn id="33" dur="600" fill="hold"/>
+                                        <p:tgtEl>
+                                          <p:spTgt spid="9"/>
+                                        </p:tgtEl>
+                                        <p:attrNameLst>
+                                          <p:attrName>ppt_y</p:attrName>
+                                        </p:attrNameLst>
+                                      </p:cBhvr>
+                                      <p:tavLst>
+                                        <p:tav tm="0">
+                                          <p:val>
+                                            <p:strVal val="#ppt_y+.06"/>
+                                          </p:val>
+                                        </p:tav>
+                                        <p:tav tm="100000">
+                                          <p:val>
+                                            <p:strVal val="#ppt_y"/>
+                                          </p:val>
+                                        </p:tav>
+                                      </p:tavLst>
+                                    </p:anim>
+                                  </p:childTnLst>
+                                </p:cTn>
+                              </p:par>
+                            </p:childTnLst>
+                          </p:cTn>
+                        </p:par>
+                        <p:par>
+                          <p:cTn id="34" fill="hold">
+                            <p:stCondLst>
+                              <p:cond delay="2280"/>
+                            </p:stCondLst>
+                            <p:childTnLst>
+                              <p:par>
+                                <p:cTn id="35" presetID="42" presetClass="entr" presetSubtype="0" fill="hold" grpId="0" nodeType="afterEffect">
+                                  <p:stCondLst>
+                                    <p:cond delay="80"/>
+                                  </p:stCondLst>
+                                  <p:childTnLst>
+                                    <p:set>
+                                      <p:cBhvr>
+                                        <p:cTn id="36" dur="1" fill="hold">
+                                          <p:stCondLst>
+                                            <p:cond delay="0"/>
+                                          </p:stCondLst>
+                                        </p:cTn>
+                                        <p:tgtEl>
+                                          <p:spTgt spid="10"/>
+                                        </p:tgtEl>
+                                        <p:attrNameLst>
+                                          <p:attrName>style.visibility</p:attrName>
+                                        </p:attrNameLst>
+                                      </p:cBhvr>
+                                      <p:to>
+                                        <p:strVal val="visible"/>
+                                      </p:to>
+                                    </p:set>
+                                    <p:animEffect transition="in" filter="fade">
+                                      <p:cBhvr>
+                                        <p:cTn id="37" dur="600"/>
+                                        <p:tgtEl>
+                                          <p:spTgt spid="10"/>
+                                        </p:tgtEl>
+                                      </p:cBhvr>
+                                    </p:animEffect>
+                                    <p:anim calcmode="lin" valueType="num">
+                                      <p:cBhvr>
+                                        <p:cTn id="38" dur="600" fill="hold"/>
+                                        <p:tgtEl>
+                                          <p:spTgt spid="10"/>
+                                        </p:tgtEl>
+                                        <p:attrNameLst>
+                                          <p:attrName>ppt_x</p:attrName>
+                                        </p:attrNameLst>
+                                      </p:cBhvr>
+                                      <p:tavLst>
+                                        <p:tav tm="0">
+                                          <p:val>
+                                            <p:strVal val="#ppt_x"/>
+                                          </p:val>
+                                        </p:tav>
+                                        <p:tav tm="100000">
+                                          <p:val>
+                                            <p:strVal val="#ppt_x"/>
+                                          </p:val>
+                                        </p:tav>
+                                      </p:tavLst>
+                                    </p:anim>
+                                    <p:anim calcmode="lin" valueType="num">
+                                      <p:cBhvr>
+                                        <p:cTn id="39" dur="600" fill="hold"/>
+                                        <p:tgtEl>
+                                          <p:spTgt spid="10"/>
+                                        </p:tgtEl>
+                                        <p:attrNameLst>
+                                          <p:attrName>ppt_y</p:attrName>
+                                        </p:attrNameLst>
+                                      </p:cBhvr>
+                                      <p:tavLst>
+                                        <p:tav tm="0">
+                                          <p:val>
+                                            <p:strVal val="#ppt_y+.06"/>
+                                          </p:val>
+                                        </p:tav>
+                                        <p:tav tm="100000">
+                                          <p:val>
+                                            <p:strVal val="#ppt_y"/>
+                                          </p:val>
+                                        </p:tav>
+                                      </p:tavLst>
+                                    </p:anim>
+                                  </p:childTnLst>
+                                </p:cTn>
+                              </p:par>
+                              <p:par>
+                                <p:cTn id="40" presetID="42" presetClass="entr" presetSubtype="0" fill="hold" grpId="0" nodeType="withEffect">
+                                  <p:stCondLst>
+                                    <p:cond delay="0"/>
+                                  </p:stCondLst>
+                                  <p:childTnLst>
+                                    <p:set>
+                                      <p:cBhvr>
+                                        <p:cTn id="41" dur="1" fill="hold">
+                                          <p:stCondLst>
+                                            <p:cond delay="0"/>
+                                          </p:stCondLst>
+                                        </p:cTn>
+                                        <p:tgtEl>
+                                          <p:spTgt spid="11"/>
+                                        </p:tgtEl>
+                                        <p:attrNameLst>
+                                          <p:attrName>style.visibility</p:attrName>
+                                        </p:attrNameLst>
+                                      </p:cBhvr>
+                                      <p:to>
+                                        <p:strVal val="visible"/>
+                                      </p:to>
+                                    </p:set>
+                                    <p:animEffect transition="in" filter="fade">
+                                      <p:cBhvr>
+                                        <p:cTn id="42" dur="600"/>
+                                        <p:tgtEl>
+                                          <p:spTgt spid="11"/>
+                                        </p:tgtEl>
+                                      </p:cBhvr>
+                                    </p:animEffect>
+                                    <p:anim calcmode="lin" valueType="num">
+                                      <p:cBhvr>
+                                        <p:cTn id="43" dur="600" fill="hold"/>
+                                        <p:tgtEl>
+                                          <p:spTgt spid="11"/>
+                                        </p:tgtEl>
+                                        <p:attrNameLst>
+                                          <p:attrName>ppt_x</p:attrName>
+                                        </p:attrNameLst>
+                                      </p:cBhvr>
+                                      <p:tavLst>
+                                        <p:tav tm="0">
+                                          <p:val>
+                                            <p:strVal val="#ppt_x"/>
+                                          </p:val>
+                                        </p:tav>
+                                        <p:tav tm="100000">
+                                          <p:val>
+                                            <p:strVal val="#ppt_x"/>
+                                          </p:val>
+                                        </p:tav>
+                                      </p:tavLst>
+                                    </p:anim>
+                                    <p:anim calcmode="lin" valueType="num">
+                                      <p:cBhvr>
+                                        <p:cTn id="44" dur="600" fill="hold"/>
+                                        <p:tgtEl>
+                                          <p:spTgt spid="11"/>
+                                        </p:tgtEl>
+                                        <p:attrNameLst>
+                                          <p:attrName>ppt_y</p:attrName>
+                                        </p:attrNameLst>
+                                      </p:cBhvr>
+                                      <p:tavLst>
+                                        <p:tav tm="0">
+                                          <p:val>
+                                            <p:strVal val="#ppt_y+.06"/>
+                                          </p:val>
+                                        </p:tav>
+                                        <p:tav tm="100000">
+                                          <p:val>
+                                            <p:strVal val="#ppt_y"/>
+                                          </p:val>
+                                        </p:tav>
+                                      </p:tavLst>
+                                    </p:anim>
+                                  </p:childTnLst>
+                                </p:cTn>
+                              </p:par>
+                            </p:childTnLst>
+                          </p:cTn>
+                        </p:par>
+                        <p:par>
+                          <p:cTn id="45" fill="hold">
+                            <p:stCondLst>
+                              <p:cond delay="2960"/>
+                            </p:stCondLst>
+                            <p:childTnLst>
+                              <p:par>
+                                <p:cTn id="46" presetID="42" presetClass="entr" presetSubtype="0" fill="hold" grpId="0" nodeType="afterEffect">
+                                  <p:stCondLst>
+                                    <p:cond delay="80"/>
+                                  </p:stCondLst>
+                                  <p:childTnLst>
+                                    <p:set>
+                                      <p:cBhvr>
+                                        <p:cTn id="47" dur="1" fill="hold">
+                                          <p:stCondLst>
+                                            <p:cond delay="0"/>
+                                          </p:stCondLst>
+                                        </p:cTn>
+                                        <p:tgtEl>
+                                          <p:spTgt spid="12"/>
+                                        </p:tgtEl>
+                                        <p:attrNameLst>
+                                          <p:attrName>style.visibility</p:attrName>
+                                        </p:attrNameLst>
+                                      </p:cBhvr>
+                                      <p:to>
+                                        <p:strVal val="visible"/>
+                                      </p:to>
+                                    </p:set>
+                                    <p:animEffect transition="in" filter="fade">
+                                      <p:cBhvr>
+                                        <p:cTn id="48" dur="600"/>
+                                        <p:tgtEl>
+                                          <p:spTgt spid="12"/>
+                                        </p:tgtEl>
+                                      </p:cBhvr>
+                                    </p:animEffect>
+                                    <p:anim calcmode="lin" valueType="num">
+                                      <p:cBhvr>
+                                        <p:cTn id="49" dur="600" fill="hold"/>
+                                        <p:tgtEl>
+                                          <p:spTgt spid="12"/>
+                                        </p:tgtEl>
+                                        <p:attrNameLst>
+                                          <p:attrName>ppt_x</p:attrName>
+                                        </p:attrNameLst>
+                                      </p:cBhvr>
+                                      <p:tavLst>
+                                        <p:tav tm="0">
+                                          <p:val>
+                                            <p:strVal val="#ppt_x"/>
+                                          </p:val>
+                                        </p:tav>
+                                        <p:tav tm="100000">
+                                          <p:val>
+                                            <p:strVal val="#ppt_x"/>
+                                          </p:val>
+                                        </p:tav>
+                                      </p:tavLst>
+                                    </p:anim>
+                                    <p:anim calcmode="lin" valueType="num">
+                                      <p:cBhvr>
+                                        <p:cTn id="50" dur="600" fill="hold"/>
+                                        <p:tgtEl>
+                                          <p:spTgt spid="12"/>
+                                        </p:tgtEl>
+                                        <p:attrNameLst>
+                                          <p:attrName>ppt_y</p:attrName>
+                                        </p:attrNameLst>
+                                      </p:cBhvr>
+                                      <p:tavLst>
+                                        <p:tav tm="0">
+                                          <p:val>
+                                            <p:strVal val="#ppt_y+.06"/>
+                                          </p:val>
+                                        </p:tav>
+                                        <p:tav tm="100000">
+                                          <p:val>
+                                            <p:strVal val="#ppt_y"/>
+                                          </p:val>
+                                        </p:tav>
+                                      </p:tavLst>
+                                    </p:anim>
+                                  </p:childTnLst>
+                                </p:cTn>
+                              </p:par>
+                              <p:par>
+                                <p:cTn id="51" presetID="42" presetClass="entr" presetSubtype="0" fill="hold" grpId="0" nodeType="withEffect">
+                                  <p:stCondLst>
+                                    <p:cond delay="0"/>
+                                  </p:stCondLst>
+                                  <p:childTnLst>
+                                    <p:set>
+                                      <p:cBhvr>
+                                        <p:cTn id="52" dur="1" fill="hold">
+                                          <p:stCondLst>
+                                            <p:cond delay="0"/>
+                                          </p:stCondLst>
+                                        </p:cTn>
+                                        <p:tgtEl>
+                                          <p:spTgt spid="13"/>
+                                        </p:tgtEl>
+                                        <p:attrNameLst>
+                                          <p:attrName>style.visibility</p:attrName>
+                                        </p:attrNameLst>
+                                      </p:cBhvr>
+                                      <p:to>
+                                        <p:strVal val="visible"/>
+                                      </p:to>
+                                    </p:set>
+                                    <p:animEffect transition="in" filter="fade">
+                                      <p:cBhvr>
+                                        <p:cTn id="53" dur="600"/>
+                                        <p:tgtEl>
+                                          <p:spTgt spid="13"/>
+                                        </p:tgtEl>
+                                      </p:cBhvr>
+                                    </p:animEffect>
+                                    <p:anim calcmode="lin" valueType="num">
+                                      <p:cBhvr>
+                                        <p:cTn id="54" dur="600" fill="hold"/>
+                                        <p:tgtEl>
+                                          <p:spTgt spid="13"/>
+                                        </p:tgtEl>
+                                        <p:attrNameLst>
+                                          <p:attrName>ppt_x</p:attrName>
+                                        </p:attrNameLst>
+                                      </p:cBhvr>
+                                      <p:tavLst>
+                                        <p:tav tm="0">
+                                          <p:val>
+                                            <p:strVal val="#ppt_x"/>
+                                          </p:val>
+                                        </p:tav>
+                                        <p:tav tm="100000">
+                                          <p:val>
+                                            <p:strVal val="#ppt_x"/>
+                                          </p:val>
+                                        </p:tav>
+                                      </p:tavLst>
+                                    </p:anim>
+                                    <p:anim calcmode="lin" valueType="num">
+                                      <p:cBhvr>
+                                        <p:cTn id="55" dur="600" fill="hold"/>
+                                        <p:tgtEl>
+                                          <p:spTgt spid="13"/>
+                                        </p:tgtEl>
+                                        <p:attrNameLst>
+                                          <p:attrName>ppt_y</p:attrName>
+                                        </p:attrNameLst>
+                                      </p:cBhvr>
+                                      <p:tavLst>
+                                        <p:tav tm="0">
+                                          <p:val>
+                                            <p:strVal val="#ppt_y+.06"/>
+                                          </p:val>
+                                        </p:tav>
+                                        <p:tav tm="100000">
+                                          <p:val>
+                                            <p:strVal val="#ppt_y"/>
+                                          </p:val>
+                                        </p:tav>
+                                      </p:tavLst>
+                                    </p:anim>
+                                  </p:childTnLst>
+                                </p:cTn>
+                              </p:par>
+                            </p:childTnLst>
+                          </p:cTn>
+                        </p:par>
+                      </p:childTnLst>
+                    </p:cTn>
+                  </p:par>
+                </p:childTnLst>
+              </p:cTn>
+              <p:prevCondLst>
+                <p:cond evt="onPrev" delay="0">
+                  <p:tgtEl>
+                    <p:sldTgt/>
+                  </p:tgtEl>
+                </p:cond>
+              </p:prevCondLst>
+              <p:nextCondLst>
+                <p:cond evt="onNext" delay="0">
+                  <p:tgtEl>
+                    <p:sldTgt/>
+                  </p:tgtEl>
+                </p:cond>
+              </p:nextCondLst>
+            </p:seq>
+          </p:childTnLst>
+        </p:cTn>
+      </p:par>
+    </p:tnLst>
+    <p:bldLst>
+      <p:bldP spid="4" grpId="0"/>
+      <p:bldP spid="5" grpId="0"/>
+      <p:bldP spid="6" grpId="0" animBg="1"/>
+      <p:bldP spid="7" grpId="0"/>
+      <p:bldP spid="8" grpId="0" animBg="1"/>
+      <p:bldP spid="9" grpId="0"/>
+      <p:bldP spid="10" grpId="0" animBg="1"/>
+      <p:bldP spid="11" grpId="0"/>
+      <p:bldP spid="12" grpId="0" animBg="1"/>
+      <p:bldP spid="13" grpId="0"/>
+    </p:bldLst>
+  </p:timing>
+</p:sld>
+</file>
+
+<file path=ppt/slides/slide9.xml><?xml version="1.0" encoding="utf-8"?>
+<p:sld xmlns:a="http://schemas.openxmlformats.org/drawingml/2006/main" xmlns:r="http://schemas.openxmlformats.org/officeDocument/2006/relationships" xmlns:p="http://schemas.openxmlformats.org/presentationml/2006/main">
+  <p:cSld name="Slide 9">
     <p:spTree>
       <p:nvGrpSpPr>
         <p:cNvPr id="1" name=""/>

</xml_diff>

<commit_message>
Harden JioMausam with expert feedback: shadow pilot, revenue split, stress test
- Phase 1 is now a 90-day Mumbai coverage audit with payouts in shadow mode;
  phase 2 moves real payouts into the IRDAI sandbox alongside the heat module
- Business case separates insurance premiums from Jio's fee revenue
- Drill book: five-page hardening chapter (fusion, path vs point, money,
  delivery-app ROI, operations, outage fallback, pilot scorecard) and
  14 expert follow-up questions (48 pages, 199 questions)
- Pitch video, recorder, voice-over script, subtitles and deck updated
- Add 25-year stress-test results

Co-Authored-By: Claude Opus 5.5 <noreply@anthropic.com>
Claude-Session: https://claude.ai/code/session_01EtNeZxsjtwkcfxMR3SBa6h
</commit_message>
<xml_diff>
--- a/reliance-tup-xii/JioMausam_3min_Presentation.pptx
+++ b/reliance-tup-xii/JioMausam_3min_Presentation.pptx
@@ -115,7 +115,7 @@
   <p:extLst>
     <p:ext uri="{521415D9-36F7-43E2-AB2F-B90AF26B5E84}">
       <p14:sectionLst xmlns:p14="http://schemas.microsoft.com/office/powerpoint/2010/main">
-        <p14:section name="Elimination round" id="{59b0ea22-44e5-95e1-4ca0-2a76dbcbf034}">
+        <p14:section name="Elimination round" id="{c1056d3a-d30f-51d1-17d9-e319d003a7fd}">
           <p14:sldIdLst>
             <p14:sldId id="256"/>
             <p14:sldId id="257"/>
@@ -5007,7 +5007,7 @@
           <a:p>
             <a:r>
               <a:rPr lang="en-US" dirty="0"/>
-              <a:t>[1:50–2:15] We start with riders, because one deal with one delivery app covers thousands of workers. Kavach Plus in Mumbai costs about ₹208 a rider a month, so fifty thousand riders is about 12.5 crore a year. In phase three, anyone can add Kavach Basic at recharge, ₹29 to ₹52 by city; one percent of Jio’s users is 174 crore a year. And insurers, states, JioMart and New Energy use the data.</a:t>
+              <a:t>[1:50–2:15] We start with riders, because one deal with one delivery app covers thousands of workers. Kavach Plus in Mumbai is about ₹208 a rider a month, so fifty thousand riders is about 12.5 crore of premiums a year. To be clear, premiums aren’t Jio’s revenue: a licensed insurer holds them, and Jio keeps fifteen to twenty-five percent as distribution and data fees. In phase three, anyone can add Kavach Basic at recharge; one percent of Jio’s users is 174 crore of premiums, or 26 to 44 crore in fees for Jio. On top of that, the data is Jio’s own revenue.</a:t>
             </a:r>
             <a:endParaRPr lang="en-US" dirty="0"/>
           </a:p>
@@ -5095,7 +5095,7 @@
           <a:p>
             <a:r>
               <a:rPr lang="en-US" dirty="0"/>
-              <a:t>[2:15–2:35] Why only Reliance? It takes five layers: a network to sense, half a billion people to reach, a way to pay, an insurer, and businesses that use the data. Reliance is the only company with all five. Our ask is small: a ninety-day Mumbai monsoon pilot with Jio’s link logs for Mumbai, one insurance partner, one delivery app and a five-person team. No new hardware. It tests our two riskiest assumptions: link coverage and payout accuracy.</a:t>
+              <a:t>[2:15–2:35] Why only Reliance? It takes five layers: a network to sense, half a billion people to reach, a way to pay, an insurer, and businesses that use the data. Reliance is the only company with all five. Our ask is small: a ninety-day Mumbai coverage audit with Jio’s link logs, one insurance partner, one delivery app and five people. Payouts run in shadow mode, so no money moves until the regulator’s sandbox. It tests our two riskiest assumptions: link coverage and payout accuracy.</a:t>
             </a:r>
             <a:endParaRPr lang="en-US" dirty="0"/>
           </a:p>
@@ -5183,7 +5183,7 @@
           <a:p>
             <a:r>
               <a:rPr lang="en-US" dirty="0"/>
-              <a:t>[2:35–2:52] Four phases. Phase one is the Mumbai monsoon pilot: rain, riders, one delivery app. Phase two adds heatwaves in Nagpur and Ahmedabad. Phase three puts Kavach Basic on every recharge. Phase four is a national map with data for insurers and states.</a:t>
+              <a:t>[2:35–2:52] Four phases. Phase one is a Mumbai coverage audit with payouts in shadow mode: rain, riders, one delivery app. Phase two moves to real payouts in IRDAI’s sandbox and adds heatwaves in Nagpur and Ahmedabad. Phase three puts Kavach Basic on every recharge. Phase four is a national map with data for insurers and states.</a:t>
             </a:r>
             <a:endParaRPr lang="en-US" dirty="0"/>
           </a:p>
@@ -10937,7 +10937,7 @@
                 <a:ea typeface="Calibri" pitchFamily="34" charset="-122"/>
                 <a:cs typeface="Calibri" pitchFamily="34" charset="-120"/>
               </a:rPr>
-              <a:t>a year from one delivery app covering 50,000 Mumbai riders on Kavach Plus (₹208 a rider a month)</a:t>
+              <a:t>of premiums a year from one delivery app covering 50,000 Mumbai riders on Kavach Plus (₹208 a rider a month)</a:t>
             </a:r>
             <a:endParaRPr lang="en-US" sz="7200" dirty="0"/>
           </a:p>
@@ -10976,7 +10976,7 @@
                 <a:ea typeface="Calibri" pitchFamily="34" charset="-122"/>
                 <a:cs typeface="Calibri" pitchFamily="34" charset="-120"/>
               </a:rPr>
-              <a:t>Riders first: one platform deal covers thousands of workers at once. Settlement is automatic, so most of the premium goes back to people.</a:t>
+              <a:t>Premiums aren’t Jio’s revenue: a licensed insurer holds them. Jio keeps 15–25% as distribution and data fees, about ₹1.9–3.1 Cr here, and carries no insurance risk.</a:t>
             </a:r>
             <a:endParaRPr lang="en-US" sz="1300" dirty="0"/>
           </a:p>
@@ -11142,7 +11142,7 @@
                 <a:ea typeface="Calibri" pitchFamily="34" charset="-122"/>
                 <a:cs typeface="Calibri" pitchFamily="34" charset="-120"/>
               </a:rPr>
-              <a:t>Individuals add it at recharge for ₹29–52 a month by city. 1% of Jio’s users = ₹174 Cr a year.</a:t>
+              <a:t>Individuals add it at recharge for ₹29–52 a month by city. 1% of Jio’s users = ₹174 Cr of premiums; Jio’s fees ₹26–44 Cr.</a:t>
             </a:r>
             <a:endParaRPr lang="en-US" sz="1800" dirty="0"/>
           </a:p>
@@ -11225,7 +11225,7 @@
                 <a:ea typeface="Calibri" pitchFamily="34" charset="-122"/>
                 <a:cs typeface="Calibri" pitchFamily="34" charset="-120"/>
               </a:rPr>
-              <a:t>Insurers and state disaster agencies license the map. JioMart, New Energy and Jio use it first.</a:t>
+              <a:t>Insurers and state disaster agencies license the map: revenue that is Jio’s own. JioMart, New Energy and Jio use it first.</a:t>
             </a:r>
             <a:endParaRPr lang="en-US" sz="1800" dirty="0"/>
           </a:p>
@@ -12638,7 +12638,7 @@
                 <a:ea typeface="Cambria" pitchFamily="34" charset="-122"/>
                 <a:cs typeface="Cambria" pitchFamily="34" charset="-120"/>
               </a:rPr>
-              <a:t>The ask: a 90-day pilot</a:t>
+              <a:t>The ask: a 90-day coverage audit</a:t>
             </a:r>
             <a:endParaRPr lang="en-US" sz="2200" dirty="0"/>
           </a:p>
@@ -12658,7 +12658,7 @@
                 <a:ea typeface="Calibri" pitchFamily="34" charset="-122"/>
                 <a:cs typeface="Calibri" pitchFamily="34" charset="-120"/>
               </a:rPr>
-              <a:t>Mumbai monsoon: rain, riders, one delivery app.</a:t>
+              <a:t>Mumbai monsoon: rain, riders, one delivery app. Payouts in shadow mode, so no money moves yet.</a:t>
             </a:r>
             <a:endParaRPr lang="en-US" sz="2200" dirty="0"/>
           </a:p>
@@ -13585,7 +13585,7 @@
                 <a:ea typeface="Cambria" pitchFamily="34" charset="-122"/>
                 <a:cs typeface="Cambria" pitchFamily="34" charset="-120"/>
               </a:rPr>
-              <a:t>Mumbai monsoon pilot</a:t>
+              <a:t>Coverage audit + shadow pilot</a:t>
             </a:r>
             <a:endParaRPr lang="en-US" sz="5400" dirty="0"/>
           </a:p>
@@ -13605,7 +13605,7 @@
                 <a:ea typeface="Calibri" pitchFamily="34" charset="-122"/>
                 <a:cs typeface="Calibri" pitchFamily="34" charset="-120"/>
               </a:rPr>
-              <a:t>Rain, riders, one delivery app. Measure link coverage and accuracy against IMD.</a:t>
+              <a:t>Mumbai: rain, riders, one delivery app. Payouts simulated; measure links and accuracy against IMD.</a:t>
             </a:r>
             <a:endParaRPr lang="en-US" sz="5400" dirty="0"/>
           </a:p>
@@ -13714,7 +13714,7 @@
                 <a:ea typeface="Cambria" pitchFamily="34" charset="-122"/>
                 <a:cs typeface="Cambria" pitchFamily="34" charset="-120"/>
               </a:rPr>
-              <a:t>Heatwaves</a:t>
+              <a:t>Sandbox + heat</a:t>
             </a:r>
             <a:endParaRPr lang="en-US" sz="5400" dirty="0"/>
           </a:p>
@@ -13734,7 +13734,7 @@
                 <a:ea typeface="Calibri" pitchFamily="34" charset="-122"/>
                 <a:cs typeface="Calibri" pitchFamily="34" charset="-120"/>
               </a:rPr>
-              <a:t>Nagpur and Ahmedabad. Heat from phone and tower-site sensors.</a:t>
+              <a:t>Real payouts for one app’s riders in IRDAI’s sandbox. Heat module in Nagpur and Ahmedabad.</a:t>
             </a:r>
             <a:endParaRPr lang="en-US" sz="5400" dirty="0"/>
           </a:p>

</xml_diff>

<commit_message>
Add data pack and "How we got our numbers" explainer
- data/: the public pycomlink German files (byte-identical to the
  repository copies), CSVs of every pipeline stage, India daily IMD
  records, and a formula-driven workbook that recomputes K, the 0.95,
  the 0.88, the payout test, prices, stress test and business case
- JioMausam_How_We_Got_Our_Numbers.pdf: 21-page walkthrough from raw
  signal to price, with a worked minute and worked correlation
- Describe the German data as the pycomlink example dataset (drill
  book, deck, Test Lab, Control Room, READMEs)
- Test Lab: Mumbai's hottest recorded day was 42°C, not under 40°C

Co-Authored-By: Claude Opus 5.5 <noreply@anthropic.com>
Claude-Session: https://claude.ai/code/session_01EtNeZxsjtwkcfxMR3SBa6h
</commit_message>
<xml_diff>
--- a/reliance-tup-xii/JioMausam_3min_Presentation.pptx
+++ b/reliance-tup-xii/JioMausam_3min_Presentation.pptx
@@ -115,7 +115,7 @@
   <p:extLst>
     <p:ext uri="{521415D9-36F7-43E2-AB2F-B90AF26B5E84}">
       <p14:sectionLst xmlns:p14="http://schemas.microsoft.com/office/powerpoint/2010/main">
-        <p14:section name="Elimination round" id="{c1056d3a-d30f-51d1-17d9-e319d003a7fd}">
+        <p14:section name="Elimination round" id="{592362b4-24c5-53e4-d6d8-9a19b7a4a19e}">
           <p14:sldIdLst>
             <p14:sldId id="256"/>
             <p14:sldId id="257"/>
@@ -6601,7 +6601,7 @@
                 <a:ea typeface="Calibri" pitchFamily="34" charset="-122"/>
                 <a:cs typeface="Calibri" pitchFamily="34" charset="-120"/>
               </a:rPr>
-              <a:t>Real data: 500 commercial microwave links, 13–14 May 2018 storm (OpenSense / pycomlink sample). Reference: German Weather Service radar.</a:t>
+              <a:t>Real data: 500 commercial microwave links, 13–14 May 2018 storm (pycomlink public example data). Reference: German Weather Service radar.</a:t>
             </a:r>
             <a:endParaRPr lang="en-US" sz="950" dirty="0"/>
           </a:p>

</xml_diff>